<commit_message>
Extend deck and runbook for the Trust Center
- New slide 9, "Proving it after the fact": the KPI strip from the live Trust
  Center, the four properties that make the trail evidence rather than logging,
  and the kill-and-restart beat as the closing line.
- Demo slide reworked to "Five moves, then the receipts"; architecture slide
  gains the audit trail as a numbered component; sandbox->production table
  gains the Delta audit row; test count updated to 45.
- Fixed three pre-existing layout collisions found in visual QA: the closing
  italic on slides 5, 9 and 13 overlapped the page footer, and slide 13's
  sixth row was clipped by the slide edge after the audit row was added.
- Runbook gains move 6 (open the Trust Center) plus the kill-and-restart
  closer and an answer for "how would we prove this to an auditor?".

14 slides, all with speaker notes; validation passes.

Co-Authored-By: Claude Opus 5 <noreply@anthropic.com>
</commit_message>
<xml_diff>
--- a/IntelligenceStack_Executive_Deck.pptx
+++ b/IntelligenceStack_Executive_Deck.pptx
@@ -18,9 +18,10 @@
     <p:sldId id="266" r:id="rId12"/>
     <p:sldId id="267" r:id="rId13"/>
     <p:sldId id="268" r:id="rId14"/>
+    <p:sldId id="269" r:id="rId15"/>
   </p:sldIdLst>
   <p:notesMasterIdLst>
-    <p:notesMasterId r:id="rId15"/>
+    <p:notesMasterId r:id="rId16"/>
   </p:notesMasterIdLst>
   <p:sldSz cx="12191695" cy="6858000"/>
   <p:notesSz cx="6858000" cy="12191695"/>
@@ -515,7 +516,7 @@
             <a:r>
               <a:rPr lang="en-US" dirty="0"/>
               <a:t>Opening line: 'Every enterprise wants to point AI at its private data. The reason they hesitate is the same one every time — the moment an LLM can see the data, it can leak it or be tricked into destroying it. IntelligenceStack is a working answer to that, not a concept.'
-Set expectations: ~10 minutes of story, then a live demo you can poke at. The whole thing runs on a laptop and computes real answers from real data — nothing on these slides is mocked.
+Set expectations: ~12 minutes of story, then a live demo you can poke at. The whole thing runs on a laptop and computes real answers from real data — nothing on these slides is mocked.
 Demo is already running: FastAPI backend on :8000, Streamlit control plane on :8501.</a:t>
             </a:r>
             <a:endParaRPr lang="en-US" dirty="0"/>
@@ -604,9 +605,9 @@
           <a:p>
             <a:r>
               <a:rPr lang="en-US" dirty="0"/>
-              <a:t>Pivot in tone here — you're done with how it works, now it's what it's worth. Four outcomes, each mapped to a number or a one-word promise the audience can repeat later.
-Lead with the one that matters most to THIS room. For a CFO, cost. For a CISO, unblocked adoption. For a business unit, days-to-seconds. Read the room and reorder verbally.
-The strongest strategic argument is the second tile: most enterprise GenAI initiatives don't fail on capability, they stall in security review. This architecture is what gets them unstuck — that's the real ROI, and it's larger than any single use case.</a:t>
+              <a:t>For the technical people in the room. The histogram shows why the anomaly call is trustworthy: normal traffic clusters near 66ms, the 3σ line sits at 310ms, and the anomaly cohort lives in the far right tail. Nobody picked 310 — it's three standard deviations of the actual data.
+The three bullets are the engineering credibility: statistical definition, bound parameters, durable tracing. If a CTO or architect is evaluating this, these are the words that say it was built by someone who has shipped production data systems.
+Close on the tests: each claim on these slides has an automated test that fails loudly if it regresses — including one that asserts the agent keeps working when the audit sink is broken.</a:t>
             </a:r>
             <a:endParaRPr lang="en-US" dirty="0"/>
           </a:p>
@@ -694,9 +695,9 @@
           <a:p>
             <a:r>
               <a:rPr lang="en-US" dirty="0"/>
-              <a:t>Don't read all five — that's death by list. Name the two seats that are actually in the room and let the rest sit as evidence of breadth.
-The meta-point: this isn't a security project OR a productivity project OR a cost project. It's one architecture where each stakeholder gets a different win from the same build. That's what makes it fundable — the cost is shared across five value cases.
-Use this slide to hand off to whoever owns the next step: 'Whichever of these is your priority, the pilot looks the same.'</a:t>
+              <a:t>Pivot in tone here — you're done with how it works, now it's what it's worth. Four outcomes, each mapped to a number or a one-word promise the audience can repeat later.
+Lead with the one that matters most to THIS room. For a CFO, cost. For a CISO, unblocked adoption. For a business unit, days-to-seconds.
+The strongest strategic argument is the second tile: most enterprise GenAI initiatives don't fail on capability, they stall in security review. This architecture is what gets them unstuck — that's the real ROI, larger than any single use case.</a:t>
             </a:r>
             <a:endParaRPr lang="en-US" dirty="0"/>
           </a:p>
@@ -784,9 +785,9 @@
           <a:p>
             <a:r>
               <a:rPr lang="en-US" dirty="0"/>
-              <a:t>The objection this slide kills: 'nice demo, but it's a toy — production is a rewrite.' No. The seams are deliberate and each is a one-line swap with an identical contract.
-Row two is new and worth calling out: the retrieval index is the same story as the SQL engine. The sandbox embeds passages with TF-IDF and ranks them with in-engine cosine similarity; production embeds them with bge-large and serves them from Mosaic AI Vector Search. Same storage layout, same query contract, same citations — only the embedding changes.
-So the pilot isn't 'rebuild for prod' — it's 'repoint at the workspace.'</a:t>
+              <a:t>Don't read all five — that's death by list. Name the two seats that are actually in the room and let the rest sit as evidence of breadth.
+The meta-point: this isn't a security project OR a productivity project OR a cost project. It's one architecture where each stakeholder gets a different win from the same build. That's what makes it fundable — the cost is shared across five value cases.
+Use this slide to hand off to whoever owns the next step: 'Whichever of these is your priority, the pilot looks the same.'</a:t>
             </a:r>
             <a:endParaRPr lang="en-US" dirty="0"/>
           </a:p>
@@ -874,9 +875,9 @@
           <a:p>
             <a:r>
               <a:rPr lang="en-US" dirty="0"/>
-              <a:t>Land the plane on one sentence: the choice between AI capability and data governance was always a false one, and here's the proof running on a laptop.
-Then make the ask concrete with the three NEXT options — pick the one that matches who you're talking to. Don't leave the meeting without agreeing which dataset a pilot would point at.
-Invite them to break it: the repo is public and runs in four commands. An architecture you're willing to hand over and say 'try to get past the boundary' is a very different pitch from a slideware promise.</a:t>
+              <a:t>The objection this slide kills: 'nice demo, but it's a toy — production is a rewrite.' No. The seams are deliberate and each is a one-line swap with an identical contract.
+Two rows are worth calling out. The vector index: sandbox uses TF-IDF with in-engine cosine, production uses bge-large on Mosaic AI — same storage layout, same query contract, same citations. And the audit log: append-only JSON locally, a Delta table with retention in production — the record shape does not change.
+So the pilot isn't 'rebuild for prod' — it's 'repoint at the workspace.'</a:t>
             </a:r>
             <a:endParaRPr lang="en-US" dirty="0"/>
           </a:p>
@@ -900,6 +901,96 @@
             <a:fld id="{F7021451-1387-4CA6-816F-3879F97B5CBC}" type="slidenum">
               <a:rPr lang="en-US"/>
               <a:t>13</a:t>
+            </a:fld>
+            <a:endParaRPr lang="en-US"/>
+          </a:p>
+        </p:txBody>
+      </p:sp>
+    </p:spTree>
+    <p:extLst>
+      <p:ext uri="{BB962C8B-B14F-4D97-AF65-F5344CB8AC3E}">
+        <p14:creationId xmlns:p14="http://schemas.microsoft.com/office/powerpoint/2010/main" val="1024086991"/>
+      </p:ext>
+    </p:extLst>
+  </p:cSld>
+  <p:clrMapOvr>
+    <a:masterClrMapping/>
+  </p:clrMapOvr>
+</p:notes>
+</file>
+
+<file path=ppt/notesSlides/notesSlide14.xml><?xml version="1.0" encoding="utf-8"?>
+<p:notes xmlns:a="http://schemas.openxmlformats.org/drawingml/2006/main" xmlns:r="http://schemas.openxmlformats.org/officeDocument/2006/relationships" xmlns:p="http://schemas.openxmlformats.org/presentationml/2006/main">
+  <p:cSld>
+    <p:spTree>
+      <p:nvGrpSpPr>
+        <p:cNvPr id="1" name=""/>
+        <p:cNvGrpSpPr/>
+        <p:nvPr/>
+      </p:nvGrpSpPr>
+      <p:grpSpPr>
+        <a:xfrm>
+          <a:off x="0" y="0"/>
+          <a:ext cx="0" cy="0"/>
+          <a:chOff x="0" y="0"/>
+          <a:chExt cx="0" cy="0"/>
+        </a:xfrm>
+      </p:grpSpPr>
+      <p:sp>
+        <p:nvSpPr>
+          <p:cNvPr id="2" name="Slide Image Placeholder 1"/>
+          <p:cNvSpPr>
+            <a:spLocks noGrp="1" noRot="1" noChangeAspect="1"/>
+          </p:cNvSpPr>
+          <p:nvPr>
+            <p:ph type="sldImg"/>
+          </p:nvPr>
+        </p:nvSpPr>
+        <p:spPr/>
+      </p:sp>
+      <p:sp>
+        <p:nvSpPr>
+          <p:cNvPr id="3" name="Notes Placeholder 2"/>
+          <p:cNvSpPr>
+            <a:spLocks noGrp="1"/>
+          </p:cNvSpPr>
+          <p:nvPr>
+            <p:ph type="body" idx="1"/>
+          </p:nvPr>
+        </p:nvSpPr>
+        <p:spPr/>
+        <p:txBody>
+          <a:bodyPr/>
+          <a:lstStyle/>
+          <a:p>
+            <a:r>
+              <a:rPr lang="en-US" dirty="0"/>
+              <a:t>Land the plane on one sentence: the choice between AI capability and data governance was always a false one, and here's the proof running on a laptop.
+Then make the ask concrete with the three NEXT options — pick the one that matches who you're talking to. Don't leave the meeting without agreeing which dataset a pilot would point at.
+Invite them to break it: the repo is public and runs in four commands, and the figures on these slides reproduce exactly. An architecture you're willing to hand over and say 'try to get past the boundary' is a very different pitch from a slideware promise.</a:t>
+            </a:r>
+            <a:endParaRPr lang="en-US" dirty="0"/>
+          </a:p>
+        </p:txBody>
+      </p:sp>
+      <p:sp>
+        <p:nvSpPr>
+          <p:cNvPr id="4" name="Slide Number Placeholder 3"/>
+          <p:cNvSpPr>
+            <a:spLocks noGrp="1"/>
+          </p:cNvSpPr>
+          <p:nvPr>
+            <p:ph type="sldNum" sz="quarter" idx="10"/>
+          </p:nvPr>
+        </p:nvSpPr>
+        <p:spPr/>
+        <p:txBody>
+          <a:bodyPr/>
+          <a:lstStyle/>
+          <a:p>
+            <a:fld id="{F7021451-1387-4CA6-816F-3879F97B5CBC}" type="slidenum">
+              <a:rPr lang="en-US"/>
+              <a:t>14</a:t>
             </a:fld>
             <a:endParaRPr lang="en-US"/>
           </a:p>
@@ -1056,7 +1147,7 @@
               <a:rPr lang="en-US" dirty="0"/>
               <a:t>The vending-machine analogy lands well here: 'We don't give the AI keys to the warehouse. We give it a vending machine with a fixed set of buttons. It's very good at choosing the right button — but it physically cannot reach behind the glass.'
 The right-hand column is the whole thesis. Every later slide is evidence for one of those four lines.
-Emphasize the last bullet on each side: the shift from 'trust us' to 'here is the allowlist' is what actually unblocks projects in security review.</a:t>
+Note the last bullet says 'here is the evidence', not 'here is the allowlist' — since the Trust Center, you can show the actual record of what the AI did, not just what it was permitted to do.</a:t>
             </a:r>
             <a:endParaRPr lang="en-US" dirty="0"/>
           </a:p>
@@ -1145,7 +1236,7 @@
             <a:r>
               <a:rPr lang="en-US" dirty="0"/>
               <a:t>Walk the diagram left to right, but keep it to one sentence per numbered item — executives don't need the plumbing, they need to see there IS plumbing.
-The one line to land: the boundary sits between the agent and the data. The agent never touches tables directly; it can only ask the catalog to run a named, pre-approved function. Item 4 extends that same rule to unstructured knowledge — retrieval is a governed tool like any other.
+The one line to land: the boundary sits between the agent and the data. The agent never touches tables directly; it can only ask the catalog to run a named, pre-approved function. Item 4 extends that same rule to unstructured knowledge, and item 5 makes every one of those decisions durable evidence.
 If someone asks 'is this really Databricks?' — yes: DLT, Unity Catalog, Liquid Clustering, Model Serving, Mosaic AI Vector Search. The sandbox swaps each for a local stand-in with the same contract.</a:t>
             </a:r>
             <a:endParaRPr lang="en-US" dirty="0"/>
@@ -1236,8 +1327,8 @@
               <a:rPr lang="en-US" dirty="0"/>
               <a:t>This is the switch-to-live-app slide. Leave it up while you alt-tab to the control plane at localhost:8501.
 Run order matters: lead with value (moves 1 and 2) so the room sees the point before the security material. Then 3, 4 and 5 answer 'but can I trust it?' — by trying to break it in front of them.
-For each move, read the trace panel aloud: Intent Resolution → Governance Boundary Check → Execution. Move 2 is the one to linger on — the trace shows TWO governance checks, one per tool.
-If the live app misbehaves, slides 6 through 9 carry the same content as static backup — just present those.</a:t>
+For each move, read the trace panel aloud. Move 2 is the one to linger on — the trace shows TWO governance checks, one per tool.
+Then finish on the Trust Center: the five things you just did are already recorded. That closing beat is what turns a demo into an audit story.</a:t>
             </a:r>
             <a:endParaRPr lang="en-US" dirty="0"/>
           </a:p>
@@ -1327,7 +1418,7 @@
               <a:rPr lang="en-US" dirty="0"/>
               <a:t>The headline: the agent did not retrieve a canned sentence. It called the anomaly function, got rows back, and phrased them. The chart is the same data, drawn independently — three biased-cohort customers separate cleanly from ~57 normal ones.
 The stat tiles are the 'so what': 82% of this customer's traffic is anomalous, at 6x normal latency. That is an actionable finding a business owner can act on today.
-Swap CUST_404 for CUST_405 live and watch it drop to 0% — that improvisation always convinces the skeptic.</a:t>
+The italic line matters for credibility: these numbers are reproducible, not screenshots. Anyone can clone and verify. Swap CUST_404 for CUST_405 live and watch it drop to 0%.</a:t>
             </a:r>
             <a:endParaRPr lang="en-US" dirty="0"/>
           </a:p>
@@ -1416,8 +1507,8 @@
             <a:r>
               <a:rPr lang="en-US" dirty="0"/>
               <a:t>This is the slide that shows the architecture has matured beyond 'query a table'. A real operational question needs two different kinds of knowledge — a measurement and a procedure — and until now those lived in two different systems with two different access models.
-The key governance point, and say it explicitly: retrieval did not get a special exemption. It is a registered function on the same allowlist, its question is passed as a bound value, and it produced its OWN governance check. In the live trace the room can count two 'Granted' entries.
-The closing line is the one to land: the number is from the lakehouse, the recommendation is from an approved document, and the model authored neither. It orchestrated. That is the whole thesis, demonstrated on one question.</a:t>
+The key governance point, and say it explicitly: retrieval did not get a special exemption. It is a registered function on the same allowlist, its question is passed as a bound value, and it produced its OWN governance check. In the live trace the room can count two 'Granted' entries — and both are separately recorded in the audit trail.
+The closing line is the one to land: the number is from the lakehouse, the recommendation is from an approved document, and the model authored neither. It orchestrated.</a:t>
             </a:r>
             <a:endParaRPr lang="en-US" dirty="0"/>
           </a:p>
@@ -1508,7 +1599,7 @@
               <a:t>This slide is aimed squarely at anyone who has been burned by a RAG pilot. Every one of them has seen a demo where the system cheerfully cites an irrelevant document, and it is the reason many of those pilots never shipped.
 Walk the chart left to right. The left panel is the trap: if you rank purely by similarity — which is what most RAG implementations do — the off-topic question WINS. That is measured on this corpus, not hypothetical.
 The right panel is the fix: require that the question's vocabulary is actually covered by the corpus. Off-topic falls below the line and the system declines.
-The engineering maturity signal here is knowing that a retrieval system needs an abstention policy at all. Most teams discover this in production, after a bad answer reaches a customer.</a:t>
+The maturity signal is knowing a retrieval system needs an abstention policy at all. Most teams discover this in production, after a bad answer reaches a customer.</a:t>
             </a:r>
             <a:endParaRPr lang="en-US" dirty="0"/>
           </a:p>
@@ -1596,9 +1687,11 @@
           <a:p>
             <a:r>
               <a:rPr lang="en-US" dirty="0"/>
-              <a:t>For the technical people in the room. The histogram shows why the anomaly call is trustworthy: normal traffic clusters near 66ms, the 3σ line sits at 310ms, and the anomaly cohort lives in the far right tail. Nobody picked 310 — it's three standard deviations of the actual data.
-The three bullets are the engineering credibility: statistical definition, bound parameters, full tracing. If a CTO or architect is evaluating this, these are the words that say it was built by someone who has shipped production data systems.
-Close on the tests: each claim on these slides has an automated test that fails loudly if it regresses.</a:t>
+              <a:t>This is the CISO and Compliance slide, and it is the natural close to the live demo — you have just done five things, now show the room that all five are already on the record.
+The framing that matters: a control you cannot evidence is a control you cannot pass an audit with. Most AI governance stories stop at 'we have a policy'. This one produces a queryable record of every decision the boundary made, including every refusal.
+Call out the refusal count deliberately. A denial is not an error to be embarrassed about — it is the single best piece of evidence that the control is live and working, and auditors treat it that way.
+If you want a memorable beat: kill the API in front of them, restart it, and reload the tab. The trail is unchanged. That is what separates evidence from logging.
+Production note if asked: this is a Delta table with retention and access policy applied, or shipped to your SIEM — the record shape is identical.</a:t>
             </a:r>
             <a:endParaRPr lang="en-US" dirty="0"/>
           </a:p>
@@ -2377,6 +2470,580 @@
                 <a:ea typeface="Calibri" pitchFamily="34" charset="-122"/>
                 <a:cs typeface="Calibri" pitchFamily="34" charset="-120"/>
               </a:rPr>
+              <a:t>UNDER THE HOOD</a:t>
+            </a:r>
+            <a:endParaRPr lang="en-US" sz="1200" dirty="0"/>
+          </a:p>
+        </p:txBody>
+      </p:sp>
+      <p:sp>
+        <p:nvSpPr>
+          <p:cNvPr id="4" name="Text 2"/>
+          <p:cNvSpPr/>
+          <p:nvPr/>
+        </p:nvSpPr>
+        <p:spPr>
+          <a:xfrm>
+            <a:off x="640080" y="841248"/>
+            <a:ext cx="10881360" cy="914400"/>
+          </a:xfrm>
+          <a:prstGeom prst="rect">
+            <a:avLst/>
+          </a:prstGeom>
+          <a:noFill/>
+          <a:ln/>
+        </p:spPr>
+        <p:txBody>
+          <a:bodyPr wrap="square" lIns="0" tIns="0" rIns="0" bIns="0" rtlCol="0" anchor="t"/>
+          <a:lstStyle/>
+          <a:p>
+            <a:pPr indent="0" marL="0">
+              <a:buNone/>
+            </a:pPr>
+            <a:r>
+              <a:rPr lang="en-US" sz="3200" b="1" dirty="0">
+                <a:solidFill>
+                  <a:srgbClr val="E9EEF3"/>
+                </a:solidFill>
+                <a:latin typeface="Cambria" pitchFamily="34" charset="0"/>
+                <a:ea typeface="Cambria" pitchFamily="34" charset="-122"/>
+                <a:cs typeface="Cambria" pitchFamily="34" charset="-120"/>
+              </a:rPr>
+              <a:t>Why the answers hold up</a:t>
+            </a:r>
+            <a:endParaRPr lang="en-US" sz="3200" dirty="0"/>
+          </a:p>
+        </p:txBody>
+      </p:sp>
+      <p:pic>
+        <p:nvPicPr>
+          <p:cNvPr id="5" name="Image 0" descr="/private/tmp/claude-501/-Users-atharvvani-Downloads-DataBricks/437ba0b1-41b9-48e1-95cf-333721d11260/scratchpad/deck_assets/latency_dist.png">    </p:cNvPr>
+          <p:cNvPicPr>
+            <a:picLocks noChangeAspect="1"/>
+          </p:cNvPicPr>
+          <p:nvPr/>
+        </p:nvPicPr>
+        <p:blipFill>
+          <a:blip r:embed="rId1"/>
+          <a:stretch>
+            <a:fillRect/>
+          </a:stretch>
+        </p:blipFill>
+        <p:spPr>
+          <a:xfrm>
+            <a:off x="640080" y="1828800"/>
+            <a:ext cx="6766560" cy="2926080"/>
+          </a:xfrm>
+          <a:prstGeom prst="rect">
+            <a:avLst/>
+          </a:prstGeom>
+        </p:spPr>
+      </p:pic>
+      <p:sp>
+        <p:nvSpPr>
+          <p:cNvPr id="6" name="Shape 3"/>
+          <p:cNvSpPr/>
+          <p:nvPr/>
+        </p:nvSpPr>
+        <p:spPr>
+          <a:xfrm>
+            <a:off x="7772400" y="1764792"/>
+            <a:ext cx="146304" cy="146304"/>
+          </a:xfrm>
+          <a:prstGeom prst="ellipse">
+            <a:avLst/>
+          </a:prstGeom>
+          <a:solidFill>
+            <a:srgbClr val="FF6C00"/>
+          </a:solidFill>
+          <a:ln/>
+        </p:spPr>
+      </p:sp>
+      <p:sp>
+        <p:nvSpPr>
+          <p:cNvPr id="7" name="Text 4"/>
+          <p:cNvSpPr/>
+          <p:nvPr/>
+        </p:nvSpPr>
+        <p:spPr>
+          <a:xfrm>
+            <a:off x="8046720" y="1645920"/>
+            <a:ext cx="3474720" cy="365760"/>
+          </a:xfrm>
+          <a:prstGeom prst="rect">
+            <a:avLst/>
+          </a:prstGeom>
+          <a:noFill/>
+          <a:ln/>
+        </p:spPr>
+        <p:txBody>
+          <a:bodyPr wrap="square" lIns="0" tIns="0" rIns="0" bIns="0" rtlCol="0" anchor="ctr"/>
+          <a:lstStyle/>
+          <a:p>
+            <a:pPr indent="0" marL="0">
+              <a:buNone/>
+            </a:pPr>
+            <a:r>
+              <a:rPr lang="en-US" sz="1550" b="1" dirty="0">
+                <a:solidFill>
+                  <a:srgbClr val="E9EEF3"/>
+                </a:solidFill>
+                <a:latin typeface="Calibri" pitchFamily="34" charset="0"/>
+                <a:ea typeface="Calibri" pitchFamily="34" charset="-122"/>
+                <a:cs typeface="Calibri" pitchFamily="34" charset="-120"/>
+              </a:rPr>
+              <a:t>Statistical, not hard-coded</a:t>
+            </a:r>
+            <a:endParaRPr lang="en-US" sz="1550" dirty="0"/>
+          </a:p>
+        </p:txBody>
+      </p:sp>
+      <p:sp>
+        <p:nvSpPr>
+          <p:cNvPr id="8" name="Text 5"/>
+          <p:cNvSpPr/>
+          <p:nvPr/>
+        </p:nvSpPr>
+        <p:spPr>
+          <a:xfrm>
+            <a:off x="8046720" y="2029968"/>
+            <a:ext cx="3474720" cy="822960"/>
+          </a:xfrm>
+          <a:prstGeom prst="rect">
+            <a:avLst/>
+          </a:prstGeom>
+          <a:noFill/>
+          <a:ln/>
+        </p:spPr>
+        <p:txBody>
+          <a:bodyPr wrap="square" lIns="0" tIns="0" rIns="0" bIns="0" rtlCol="0" anchor="ctr"/>
+          <a:lstStyle/>
+          <a:p>
+            <a:pPr indent="0" marL="0">
+              <a:lnSpc>
+                <a:spcPct val="108000"/>
+              </a:lnSpc>
+              <a:buNone/>
+            </a:pPr>
+            <a:r>
+              <a:rPr lang="en-US" sz="1250" dirty="0">
+                <a:solidFill>
+                  <a:srgbClr val="93A1AF"/>
+                </a:solidFill>
+                <a:latin typeface="Calibri" pitchFamily="34" charset="0"/>
+                <a:ea typeface="Calibri" pitchFamily="34" charset="-122"/>
+                <a:cs typeface="Calibri" pitchFamily="34" charset="-120"/>
+              </a:rPr>
+              <a:t>Anomalies are events beyond 3σ of the live population — the threshold moves with the data, not a magic number.</a:t>
+            </a:r>
+            <a:endParaRPr lang="en-US" sz="1250" dirty="0"/>
+          </a:p>
+        </p:txBody>
+      </p:sp>
+      <p:sp>
+        <p:nvSpPr>
+          <p:cNvPr id="9" name="Shape 6"/>
+          <p:cNvSpPr/>
+          <p:nvPr/>
+        </p:nvSpPr>
+        <p:spPr>
+          <a:xfrm>
+            <a:off x="7772400" y="3099816"/>
+            <a:ext cx="146304" cy="146304"/>
+          </a:xfrm>
+          <a:prstGeom prst="ellipse">
+            <a:avLst/>
+          </a:prstGeom>
+          <a:solidFill>
+            <a:srgbClr val="FF6C00"/>
+          </a:solidFill>
+          <a:ln/>
+        </p:spPr>
+      </p:sp>
+      <p:sp>
+        <p:nvSpPr>
+          <p:cNvPr id="10" name="Text 7"/>
+          <p:cNvSpPr/>
+          <p:nvPr/>
+        </p:nvSpPr>
+        <p:spPr>
+          <a:xfrm>
+            <a:off x="8046720" y="2980944"/>
+            <a:ext cx="3474720" cy="365760"/>
+          </a:xfrm>
+          <a:prstGeom prst="rect">
+            <a:avLst/>
+          </a:prstGeom>
+          <a:noFill/>
+          <a:ln/>
+        </p:spPr>
+        <p:txBody>
+          <a:bodyPr wrap="square" lIns="0" tIns="0" rIns="0" bIns="0" rtlCol="0" anchor="ctr"/>
+          <a:lstStyle/>
+          <a:p>
+            <a:pPr indent="0" marL="0">
+              <a:buNone/>
+            </a:pPr>
+            <a:r>
+              <a:rPr lang="en-US" sz="1550" b="1" dirty="0">
+                <a:solidFill>
+                  <a:srgbClr val="E9EEF3"/>
+                </a:solidFill>
+                <a:latin typeface="Calibri" pitchFamily="34" charset="0"/>
+                <a:ea typeface="Calibri" pitchFamily="34" charset="-122"/>
+                <a:cs typeface="Calibri" pitchFamily="34" charset="-120"/>
+              </a:rPr>
+              <a:t>Parameter-bound execution</a:t>
+            </a:r>
+            <a:endParaRPr lang="en-US" sz="1550" dirty="0"/>
+          </a:p>
+        </p:txBody>
+      </p:sp>
+      <p:sp>
+        <p:nvSpPr>
+          <p:cNvPr id="11" name="Text 8"/>
+          <p:cNvSpPr/>
+          <p:nvPr/>
+        </p:nvSpPr>
+        <p:spPr>
+          <a:xfrm>
+            <a:off x="8046720" y="3364992"/>
+            <a:ext cx="3474720" cy="822960"/>
+          </a:xfrm>
+          <a:prstGeom prst="rect">
+            <a:avLst/>
+          </a:prstGeom>
+          <a:noFill/>
+          <a:ln/>
+        </p:spPr>
+        <p:txBody>
+          <a:bodyPr wrap="square" lIns="0" tIns="0" rIns="0" bIns="0" rtlCol="0" anchor="ctr"/>
+          <a:lstStyle/>
+          <a:p>
+            <a:pPr indent="0" marL="0">
+              <a:lnSpc>
+                <a:spcPct val="108000"/>
+              </a:lnSpc>
+              <a:buNone/>
+            </a:pPr>
+            <a:r>
+              <a:rPr lang="en-US" sz="1250" dirty="0">
+                <a:solidFill>
+                  <a:srgbClr val="93A1AF"/>
+                </a:solidFill>
+                <a:latin typeface="Calibri" pitchFamily="34" charset="0"/>
+                <a:ea typeface="Calibri" pitchFamily="34" charset="-122"/>
+                <a:cs typeface="Calibri" pitchFamily="34" charset="-120"/>
+              </a:rPr>
+              <a:t>Values are bound, never interpolated — a hostile input matches no rows and cannot reshape a query.</a:t>
+            </a:r>
+            <a:endParaRPr lang="en-US" sz="1250" dirty="0"/>
+          </a:p>
+        </p:txBody>
+      </p:sp>
+      <p:sp>
+        <p:nvSpPr>
+          <p:cNvPr id="12" name="Shape 9"/>
+          <p:cNvSpPr/>
+          <p:nvPr/>
+        </p:nvSpPr>
+        <p:spPr>
+          <a:xfrm>
+            <a:off x="7772400" y="4434840"/>
+            <a:ext cx="146304" cy="146304"/>
+          </a:xfrm>
+          <a:prstGeom prst="ellipse">
+            <a:avLst/>
+          </a:prstGeom>
+          <a:solidFill>
+            <a:srgbClr val="FF6C00"/>
+          </a:solidFill>
+          <a:ln/>
+        </p:spPr>
+      </p:sp>
+      <p:sp>
+        <p:nvSpPr>
+          <p:cNvPr id="13" name="Text 10"/>
+          <p:cNvSpPr/>
+          <p:nvPr/>
+        </p:nvSpPr>
+        <p:spPr>
+          <a:xfrm>
+            <a:off x="8046720" y="4315968"/>
+            <a:ext cx="3474720" cy="365760"/>
+          </a:xfrm>
+          <a:prstGeom prst="rect">
+            <a:avLst/>
+          </a:prstGeom>
+          <a:noFill/>
+          <a:ln/>
+        </p:spPr>
+        <p:txBody>
+          <a:bodyPr wrap="square" lIns="0" tIns="0" rIns="0" bIns="0" rtlCol="0" anchor="ctr"/>
+          <a:lstStyle/>
+          <a:p>
+            <a:pPr indent="0" marL="0">
+              <a:buNone/>
+            </a:pPr>
+            <a:r>
+              <a:rPr lang="en-US" sz="1550" b="1" dirty="0">
+                <a:solidFill>
+                  <a:srgbClr val="E9EEF3"/>
+                </a:solidFill>
+                <a:latin typeface="Calibri" pitchFamily="34" charset="0"/>
+                <a:ea typeface="Calibri" pitchFamily="34" charset="-122"/>
+                <a:cs typeface="Calibri" pitchFamily="34" charset="-120"/>
+              </a:rPr>
+              <a:t>Every step is traced and kept</a:t>
+            </a:r>
+            <a:endParaRPr lang="en-US" sz="1550" dirty="0"/>
+          </a:p>
+        </p:txBody>
+      </p:sp>
+      <p:sp>
+        <p:nvSpPr>
+          <p:cNvPr id="14" name="Text 11"/>
+          <p:cNvSpPr/>
+          <p:nvPr/>
+        </p:nvSpPr>
+        <p:spPr>
+          <a:xfrm>
+            <a:off x="8046720" y="4700016"/>
+            <a:ext cx="3474720" cy="822960"/>
+          </a:xfrm>
+          <a:prstGeom prst="rect">
+            <a:avLst/>
+          </a:prstGeom>
+          <a:noFill/>
+          <a:ln/>
+        </p:spPr>
+        <p:txBody>
+          <a:bodyPr wrap="square" lIns="0" tIns="0" rIns="0" bIns="0" rtlCol="0" anchor="ctr"/>
+          <a:lstStyle/>
+          <a:p>
+            <a:pPr indent="0" marL="0">
+              <a:lnSpc>
+                <a:spcPct val="108000"/>
+              </a:lnSpc>
+              <a:buNone/>
+            </a:pPr>
+            <a:r>
+              <a:rPr lang="en-US" sz="1250" dirty="0">
+                <a:solidFill>
+                  <a:srgbClr val="93A1AF"/>
+                </a:solidFill>
+                <a:latin typeface="Calibri" pitchFamily="34" charset="0"/>
+                <a:ea typeface="Calibri" pitchFamily="34" charset="-122"/>
+                <a:cs typeface="Calibri" pitchFamily="34" charset="-120"/>
+              </a:rPr>
+              <a:t>Intent, each governance decision, execution, synthesis — recorded live and persisted for audit.</a:t>
+            </a:r>
+            <a:endParaRPr lang="en-US" sz="1250" dirty="0"/>
+          </a:p>
+        </p:txBody>
+      </p:sp>
+      <p:sp>
+        <p:nvSpPr>
+          <p:cNvPr id="15" name="Text 12"/>
+          <p:cNvSpPr/>
+          <p:nvPr/>
+        </p:nvSpPr>
+        <p:spPr>
+          <a:xfrm>
+            <a:off x="640080" y="5943600"/>
+            <a:ext cx="10881360" cy="457200"/>
+          </a:xfrm>
+          <a:prstGeom prst="rect">
+            <a:avLst/>
+          </a:prstGeom>
+          <a:noFill/>
+          <a:ln/>
+        </p:spPr>
+        <p:txBody>
+          <a:bodyPr wrap="square" lIns="0" tIns="0" rIns="0" bIns="0" rtlCol="0" anchor="ctr"/>
+          <a:lstStyle/>
+          <a:p>
+            <a:pPr indent="0" marL="0">
+              <a:buNone/>
+            </a:pPr>
+            <a:r>
+              <a:rPr lang="en-US" sz="1450" i="1" dirty="0">
+                <a:solidFill>
+                  <a:srgbClr val="FF8A3D"/>
+                </a:solidFill>
+                <a:latin typeface="Calibri" pitchFamily="34" charset="0"/>
+                <a:ea typeface="Calibri" pitchFamily="34" charset="-122"/>
+                <a:cs typeface="Calibri" pitchFamily="34" charset="-120"/>
+              </a:rPr>
+              <a:t>Verified by a 45-test suite covering computation, governance, injection resistance, retrieval quality, abstention, and audit durability — all passing.</a:t>
+            </a:r>
+            <a:endParaRPr lang="en-US" sz="1450" dirty="0"/>
+          </a:p>
+        </p:txBody>
+      </p:sp>
+      <p:sp>
+        <p:nvSpPr>
+          <p:cNvPr id="16" name="Text 13"/>
+          <p:cNvSpPr/>
+          <p:nvPr/>
+        </p:nvSpPr>
+        <p:spPr>
+          <a:xfrm>
+            <a:off x="11277295" y="6400800"/>
+            <a:ext cx="548640" cy="274320"/>
+          </a:xfrm>
+          <a:prstGeom prst="rect">
+            <a:avLst/>
+          </a:prstGeom>
+          <a:noFill/>
+          <a:ln/>
+        </p:spPr>
+        <p:txBody>
+          <a:bodyPr wrap="square" lIns="0" tIns="0" rIns="0" bIns="0" rtlCol="0" anchor="ctr"/>
+          <a:lstStyle/>
+          <a:p>
+            <a:pPr algn="r" indent="0" marL="0">
+              <a:buNone/>
+            </a:pPr>
+            <a:r>
+              <a:rPr lang="en-US" sz="1000" dirty="0">
+                <a:solidFill>
+                  <a:srgbClr val="6C7C8A"/>
+                </a:solidFill>
+                <a:latin typeface="Calibri" pitchFamily="34" charset="0"/>
+                <a:ea typeface="Calibri" pitchFamily="34" charset="-122"/>
+                <a:cs typeface="Calibri" pitchFamily="34" charset="-120"/>
+              </a:rPr>
+              <a:t>10</a:t>
+            </a:r>
+            <a:endParaRPr lang="en-US" sz="1000" dirty="0"/>
+          </a:p>
+        </p:txBody>
+      </p:sp>
+      <p:sp>
+        <p:nvSpPr>
+          <p:cNvPr id="17" name="Text 14"/>
+          <p:cNvSpPr/>
+          <p:nvPr/>
+        </p:nvSpPr>
+        <p:spPr>
+          <a:xfrm>
+            <a:off x="640080" y="6400800"/>
+            <a:ext cx="3657600" cy="274320"/>
+          </a:xfrm>
+          <a:prstGeom prst="rect">
+            <a:avLst/>
+          </a:prstGeom>
+          <a:noFill/>
+          <a:ln/>
+        </p:spPr>
+        <p:txBody>
+          <a:bodyPr wrap="square" lIns="0" tIns="0" rIns="0" bIns="0" rtlCol="0" anchor="ctr"/>
+          <a:lstStyle/>
+          <a:p>
+            <a:pPr indent="0" marL="0">
+              <a:buNone/>
+            </a:pPr>
+            <a:r>
+              <a:rPr lang="en-US" sz="1000" dirty="0">
+                <a:solidFill>
+                  <a:srgbClr val="6C7C8A"/>
+                </a:solidFill>
+                <a:latin typeface="Calibri" pitchFamily="34" charset="0"/>
+                <a:ea typeface="Calibri" pitchFamily="34" charset="-122"/>
+                <a:cs typeface="Calibri" pitchFamily="34" charset="-120"/>
+              </a:rPr>
+              <a:t>IntelligenceStack</a:t>
+            </a:r>
+            <a:endParaRPr lang="en-US" sz="1000" dirty="0"/>
+          </a:p>
+        </p:txBody>
+      </p:sp>
+    </p:spTree>
+  </p:cSld>
+  <p:clrMapOvr>
+    <a:masterClrMapping/>
+  </p:clrMapOvr>
+</p:sld>
+</file>
+
+<file path=ppt/slides/slide11.xml><?xml version="1.0" encoding="utf-8"?>
+<p:sld xmlns:a="http://schemas.openxmlformats.org/drawingml/2006/main" xmlns:r="http://schemas.openxmlformats.org/officeDocument/2006/relationships" xmlns:p="http://schemas.openxmlformats.org/presentationml/2006/main">
+  <p:cSld name="Slide 11">
+    <p:bg>
+      <p:bgPr>
+        <a:solidFill>
+          <a:srgbClr val="0E1621"/>
+        </a:solidFill>
+      </p:bgPr>
+    </p:bg>
+    <p:spTree>
+      <p:nvGrpSpPr>
+        <p:cNvPr id="1" name=""/>
+        <p:cNvGrpSpPr/>
+        <p:nvPr/>
+      </p:nvGrpSpPr>
+      <p:grpSpPr>
+        <a:xfrm>
+          <a:off x="0" y="0"/>
+          <a:ext cx="0" cy="0"/>
+          <a:chOff x="0" y="0"/>
+          <a:chExt cx="0" cy="0"/>
+        </a:xfrm>
+      </p:grpSpPr>
+      <p:sp>
+        <p:nvSpPr>
+          <p:cNvPr id="2" name="Shape 0"/>
+          <p:cNvSpPr/>
+          <p:nvPr/>
+        </p:nvSpPr>
+        <p:spPr>
+          <a:xfrm>
+            <a:off x="640080" y="566928"/>
+            <a:ext cx="146304" cy="146304"/>
+          </a:xfrm>
+          <a:prstGeom prst="ellipse">
+            <a:avLst/>
+          </a:prstGeom>
+          <a:solidFill>
+            <a:srgbClr val="FF6C00"/>
+          </a:solidFill>
+          <a:ln/>
+        </p:spPr>
+      </p:sp>
+      <p:sp>
+        <p:nvSpPr>
+          <p:cNvPr id="3" name="Text 1"/>
+          <p:cNvSpPr/>
+          <p:nvPr/>
+        </p:nvSpPr>
+        <p:spPr>
+          <a:xfrm>
+            <a:off x="896112" y="457200"/>
+            <a:ext cx="9144000" cy="365760"/>
+          </a:xfrm>
+          <a:prstGeom prst="rect">
+            <a:avLst/>
+          </a:prstGeom>
+          <a:noFill/>
+          <a:ln/>
+        </p:spPr>
+        <p:txBody>
+          <a:bodyPr wrap="square" lIns="0" tIns="0" rIns="0" bIns="0" rtlCol="0" anchor="ctr"/>
+          <a:lstStyle/>
+          <a:p>
+            <a:pPr indent="0" marL="0">
+              <a:buNone/>
+            </a:pPr>
+            <a:r>
+              <a:rPr lang="en-US" sz="1200" b="1" spc="200" kern="0" dirty="0">
+                <a:solidFill>
+                  <a:srgbClr val="FF8A3D"/>
+                </a:solidFill>
+                <a:latin typeface="Calibri" pitchFamily="34" charset="0"/>
+                <a:ea typeface="Calibri" pitchFamily="34" charset="-122"/>
+                <a:cs typeface="Calibri" pitchFamily="34" charset="-120"/>
+              </a:rPr>
               <a:t>WHY IT MATTERS</a:t>
             </a:r>
             <a:endParaRPr lang="en-US" sz="1200" dirty="0"/>
@@ -2878,7 +3545,7 @@
                 <a:ea typeface="Calibri" pitchFamily="34" charset="-122"/>
                 <a:cs typeface="Calibri" pitchFamily="34" charset="-120"/>
               </a:rPr>
-              <a:t>PII hashed at ingestion, no raw-row exfiltration, per-action audit trail — controls you can demonstrate, not just promise.</a:t>
+              <a:t>PII hashed at ingestion, no raw-row exfiltration, and a durable per-action record — controls you can demonstrate, not just promise.</a:t>
             </a:r>
             <a:endParaRPr lang="en-US" sz="1250" dirty="0"/>
           </a:p>
@@ -3071,7 +3738,7 @@
                 <a:ea typeface="Calibri" pitchFamily="34" charset="-122"/>
                 <a:cs typeface="Calibri" pitchFamily="34" charset="-120"/>
               </a:rPr>
-              <a:t>10</a:t>
+              <a:t>11</a:t>
             </a:r>
             <a:endParaRPr lang="en-US" sz="1000" dirty="0"/>
           </a:p>
@@ -3124,9 +3791,9 @@
 </p:sld>
 </file>
 
-<file path=ppt/slides/slide11.xml><?xml version="1.0" encoding="utf-8"?>
+<file path=ppt/slides/slide12.xml><?xml version="1.0" encoding="utf-8"?>
 <p:sld xmlns:a="http://schemas.openxmlformats.org/drawingml/2006/main" xmlns:r="http://schemas.openxmlformats.org/officeDocument/2006/relationships" xmlns:p="http://schemas.openxmlformats.org/presentationml/2006/main">
-  <p:cSld name="Slide 11">
+  <p:cSld name="Slide 12">
     <p:bg>
       <p:bgPr>
         <a:solidFill>
@@ -3720,7 +4387,7 @@
                 <a:ea typeface="Calibri" pitchFamily="34" charset="-122"/>
                 <a:cs typeface="Calibri" pitchFamily="34" charset="-120"/>
               </a:rPr>
-              <a:t>Provable controls and a per-action audit trail that shorten review and audit cycles.</a:t>
+              <a:t>A durable, queryable record of every AI action — refusals included — that shortens review and audit cycles.</a:t>
             </a:r>
             <a:endParaRPr lang="en-US" sz="1280" dirty="0"/>
           </a:p>
@@ -4079,7 +4746,7 @@
                 <a:ea typeface="Calibri" pitchFamily="34" charset="-122"/>
                 <a:cs typeface="Calibri" pitchFamily="34" charset="-120"/>
               </a:rPr>
-              <a:t>11</a:t>
+              <a:t>12</a:t>
             </a:r>
             <a:endParaRPr lang="en-US" sz="1000" dirty="0"/>
           </a:p>
@@ -4132,9 +4799,9 @@
 </p:sld>
 </file>
 
-<file path=ppt/slides/slide12.xml><?xml version="1.0" encoding="utf-8"?>
+<file path=ppt/slides/slide13.xml><?xml version="1.0" encoding="utf-8"?>
 <p:sld xmlns:a="http://schemas.openxmlformats.org/drawingml/2006/main" xmlns:r="http://schemas.openxmlformats.org/officeDocument/2006/relationships" xmlns:p="http://schemas.openxmlformats.org/presentationml/2006/main">
-  <p:cSld name="Slide 12">
+  <p:cSld name="Slide 13">
     <p:bg>
       <p:bgPr>
         <a:solidFill>
@@ -4383,11 +5050,11 @@
         <p:spPr>
           <a:xfrm>
             <a:off x="640080" y="2788920"/>
-            <a:ext cx="4480560" cy="566928"/>
+            <a:ext cx="4480560" cy="457200"/>
           </a:xfrm>
           <a:prstGeom prst="roundRect">
             <a:avLst>
-              <a:gd name="adj" fmla="val 14516"/>
+              <a:gd name="adj" fmla="val 18000"/>
             </a:avLst>
           </a:prstGeom>
           <a:solidFill>
@@ -4417,23 +5084,23 @@
         <p:spPr>
           <a:xfrm>
             <a:off x="914400" y="2788920"/>
-            <a:ext cx="4023360" cy="566928"/>
-          </a:xfrm>
-          <a:prstGeom prst="rect">
-            <a:avLst/>
-          </a:prstGeom>
-          <a:noFill/>
-          <a:ln/>
-        </p:spPr>
-        <p:txBody>
-          <a:bodyPr wrap="square" lIns="0" tIns="0" rIns="0" bIns="0" rtlCol="0" anchor="ctr"/>
-          <a:lstStyle/>
-          <a:p>
-            <a:pPr indent="0" marL="0">
-              <a:buNone/>
-            </a:pPr>
-            <a:r>
-              <a:rPr lang="en-US" sz="1300" dirty="0">
+            <a:ext cx="4023360" cy="457200"/>
+          </a:xfrm>
+          <a:prstGeom prst="rect">
+            <a:avLst/>
+          </a:prstGeom>
+          <a:noFill/>
+          <a:ln/>
+        </p:spPr>
+        <p:txBody>
+          <a:bodyPr wrap="square" lIns="0" tIns="0" rIns="0" bIns="0" rtlCol="0" anchor="ctr"/>
+          <a:lstStyle/>
+          <a:p>
+            <a:pPr indent="0" marL="0">
+              <a:buNone/>
+            </a:pPr>
+            <a:r>
+              <a:rPr lang="en-US" sz="1200" dirty="0">
                 <a:solidFill>
                   <a:srgbClr val="E9EEF3"/>
                 </a:solidFill>
@@ -4443,7 +5110,7 @@
               </a:rPr>
               <a:t>DuckDB medallion engine</a:t>
             </a:r>
-            <a:endParaRPr lang="en-US" sz="1300" dirty="0"/>
+            <a:endParaRPr lang="en-US" sz="1200" dirty="0"/>
           </a:p>
         </p:txBody>
       </p:sp>
@@ -4455,8 +5122,8 @@
         </p:nvSpPr>
         <p:spPr>
           <a:xfrm>
-            <a:off x="5175504" y="2980944"/>
-            <a:ext cx="256032" cy="182880"/>
+            <a:off x="5175504" y="2944368"/>
+            <a:ext cx="256032" cy="146304"/>
           </a:xfrm>
           <a:prstGeom prst="rightArrow">
             <a:avLst/>
@@ -4476,11 +5143,11 @@
         <p:spPr>
           <a:xfrm>
             <a:off x="5486400" y="2788920"/>
-            <a:ext cx="6080760" cy="566928"/>
+            <a:ext cx="6080760" cy="457200"/>
           </a:xfrm>
           <a:prstGeom prst="roundRect">
             <a:avLst>
-              <a:gd name="adj" fmla="val 14516"/>
+              <a:gd name="adj" fmla="val 18000"/>
             </a:avLst>
           </a:prstGeom>
           <a:solidFill>
@@ -4510,23 +5177,23 @@
         <p:spPr>
           <a:xfrm>
             <a:off x="5760720" y="2788920"/>
-            <a:ext cx="5623560" cy="566928"/>
-          </a:xfrm>
-          <a:prstGeom prst="rect">
-            <a:avLst/>
-          </a:prstGeom>
-          <a:noFill/>
-          <a:ln/>
-        </p:spPr>
-        <p:txBody>
-          <a:bodyPr wrap="square" lIns="0" tIns="0" rIns="0" bIns="0" rtlCol="0" anchor="ctr"/>
-          <a:lstStyle/>
-          <a:p>
-            <a:pPr indent="0" marL="0">
-              <a:buNone/>
-            </a:pPr>
-            <a:r>
-              <a:rPr lang="en-US" sz="1300" dirty="0">
+            <a:ext cx="5623560" cy="457200"/>
+          </a:xfrm>
+          <a:prstGeom prst="rect">
+            <a:avLst/>
+          </a:prstGeom>
+          <a:noFill/>
+          <a:ln/>
+        </p:spPr>
+        <p:txBody>
+          <a:bodyPr wrap="square" lIns="0" tIns="0" rIns="0" bIns="0" rtlCol="0" anchor="ctr"/>
+          <a:lstStyle/>
+          <a:p>
+            <a:pPr indent="0" marL="0">
+              <a:buNone/>
+            </a:pPr>
+            <a:r>
+              <a:rPr lang="en-US" sz="1200" dirty="0">
                 <a:solidFill>
                   <a:srgbClr val="E9EEF3"/>
                 </a:solidFill>
@@ -4536,7 +5203,7 @@
               </a:rPr>
               <a:t>Serverless SQL Warehouse over Delta + Unity Catalog</a:t>
             </a:r>
-            <a:endParaRPr lang="en-US" sz="1300" dirty="0"/>
+            <a:endParaRPr lang="en-US" sz="1200" dirty="0"/>
           </a:p>
         </p:txBody>
       </p:sp>
@@ -4548,12 +5215,12 @@
         </p:nvSpPr>
         <p:spPr>
           <a:xfrm>
-            <a:off x="640080" y="3447288"/>
-            <a:ext cx="4480560" cy="566928"/>
+            <a:off x="640080" y="3319272"/>
+            <a:ext cx="4480560" cy="457200"/>
           </a:xfrm>
           <a:prstGeom prst="roundRect">
             <a:avLst>
-              <a:gd name="adj" fmla="val 14516"/>
+              <a:gd name="adj" fmla="val 18000"/>
             </a:avLst>
           </a:prstGeom>
           <a:solidFill>
@@ -4582,24 +5249,24 @@
         </p:nvSpPr>
         <p:spPr>
           <a:xfrm>
-            <a:off x="914400" y="3447288"/>
-            <a:ext cx="4023360" cy="566928"/>
-          </a:xfrm>
-          <a:prstGeom prst="rect">
-            <a:avLst/>
-          </a:prstGeom>
-          <a:noFill/>
-          <a:ln/>
-        </p:spPr>
-        <p:txBody>
-          <a:bodyPr wrap="square" lIns="0" tIns="0" rIns="0" bIns="0" rtlCol="0" anchor="ctr"/>
-          <a:lstStyle/>
-          <a:p>
-            <a:pPr indent="0" marL="0">
-              <a:buNone/>
-            </a:pPr>
-            <a:r>
-              <a:rPr lang="en-US" sz="1300" dirty="0">
+            <a:off x="914400" y="3319272"/>
+            <a:ext cx="4023360" cy="457200"/>
+          </a:xfrm>
+          <a:prstGeom prst="rect">
+            <a:avLst/>
+          </a:prstGeom>
+          <a:noFill/>
+          <a:ln/>
+        </p:spPr>
+        <p:txBody>
+          <a:bodyPr wrap="square" lIns="0" tIns="0" rIns="0" bIns="0" rtlCol="0" anchor="ctr"/>
+          <a:lstStyle/>
+          <a:p>
+            <a:pPr indent="0" marL="0">
+              <a:buNone/>
+            </a:pPr>
+            <a:r>
+              <a:rPr lang="en-US" sz="1200" dirty="0">
                 <a:solidFill>
                   <a:srgbClr val="E9EEF3"/>
                 </a:solidFill>
@@ -4609,7 +5276,7 @@
               </a:rPr>
               <a:t>TF-IDF vector index</a:t>
             </a:r>
-            <a:endParaRPr lang="en-US" sz="1300" dirty="0"/>
+            <a:endParaRPr lang="en-US" sz="1200" dirty="0"/>
           </a:p>
         </p:txBody>
       </p:sp>
@@ -4621,8 +5288,8 @@
         </p:nvSpPr>
         <p:spPr>
           <a:xfrm>
-            <a:off x="5175504" y="3639312"/>
-            <a:ext cx="256032" cy="182880"/>
+            <a:off x="5175504" y="3474720"/>
+            <a:ext cx="256032" cy="146304"/>
           </a:xfrm>
           <a:prstGeom prst="rightArrow">
             <a:avLst/>
@@ -4641,12 +5308,12 @@
         </p:nvSpPr>
         <p:spPr>
           <a:xfrm>
-            <a:off x="5486400" y="3447288"/>
-            <a:ext cx="6080760" cy="566928"/>
+            <a:off x="5486400" y="3319272"/>
+            <a:ext cx="6080760" cy="457200"/>
           </a:xfrm>
           <a:prstGeom prst="roundRect">
             <a:avLst>
-              <a:gd name="adj" fmla="val 14516"/>
+              <a:gd name="adj" fmla="val 18000"/>
             </a:avLst>
           </a:prstGeom>
           <a:solidFill>
@@ -4675,24 +5342,24 @@
         </p:nvSpPr>
         <p:spPr>
           <a:xfrm>
-            <a:off x="5760720" y="3447288"/>
-            <a:ext cx="5623560" cy="566928"/>
-          </a:xfrm>
-          <a:prstGeom prst="rect">
-            <a:avLst/>
-          </a:prstGeom>
-          <a:noFill/>
-          <a:ln/>
-        </p:spPr>
-        <p:txBody>
-          <a:bodyPr wrap="square" lIns="0" tIns="0" rIns="0" bIns="0" rtlCol="0" anchor="ctr"/>
-          <a:lstStyle/>
-          <a:p>
-            <a:pPr indent="0" marL="0">
-              <a:buNone/>
-            </a:pPr>
-            <a:r>
-              <a:rPr lang="en-US" sz="1300" dirty="0">
+            <a:off x="5760720" y="3319272"/>
+            <a:ext cx="5623560" cy="457200"/>
+          </a:xfrm>
+          <a:prstGeom prst="rect">
+            <a:avLst/>
+          </a:prstGeom>
+          <a:noFill/>
+          <a:ln/>
+        </p:spPr>
+        <p:txBody>
+          <a:bodyPr wrap="square" lIns="0" tIns="0" rIns="0" bIns="0" rtlCol="0" anchor="ctr"/>
+          <a:lstStyle/>
+          <a:p>
+            <a:pPr indent="0" marL="0">
+              <a:buNone/>
+            </a:pPr>
+            <a:r>
+              <a:rPr lang="en-US" sz="1200" dirty="0">
                 <a:solidFill>
                   <a:srgbClr val="E9EEF3"/>
                 </a:solidFill>
@@ -4702,7 +5369,7 @@
               </a:rPr>
               <a:t>Mosaic AI Vector Search (bge-large embeddings)</a:t>
             </a:r>
-            <a:endParaRPr lang="en-US" sz="1300" dirty="0"/>
+            <a:endParaRPr lang="en-US" sz="1200" dirty="0"/>
           </a:p>
         </p:txBody>
       </p:sp>
@@ -4714,12 +5381,12 @@
         </p:nvSpPr>
         <p:spPr>
           <a:xfrm>
-            <a:off x="640080" y="4105656"/>
-            <a:ext cx="4480560" cy="566928"/>
+            <a:off x="640080" y="3849624"/>
+            <a:ext cx="4480560" cy="457200"/>
           </a:xfrm>
           <a:prstGeom prst="roundRect">
             <a:avLst>
-              <a:gd name="adj" fmla="val 14516"/>
+              <a:gd name="adj" fmla="val 18000"/>
             </a:avLst>
           </a:prstGeom>
           <a:solidFill>
@@ -4748,24 +5415,24 @@
         </p:nvSpPr>
         <p:spPr>
           <a:xfrm>
-            <a:off x="914400" y="4105656"/>
-            <a:ext cx="4023360" cy="566928"/>
-          </a:xfrm>
-          <a:prstGeom prst="rect">
-            <a:avLst/>
-          </a:prstGeom>
-          <a:noFill/>
-          <a:ln/>
-        </p:spPr>
-        <p:txBody>
-          <a:bodyPr wrap="square" lIns="0" tIns="0" rIns="0" bIns="0" rtlCol="0" anchor="ctr"/>
-          <a:lstStyle/>
-          <a:p>
-            <a:pPr indent="0" marL="0">
-              <a:buNone/>
-            </a:pPr>
-            <a:r>
-              <a:rPr lang="en-US" sz="1300" dirty="0">
+            <a:off x="914400" y="3849624"/>
+            <a:ext cx="4023360" cy="457200"/>
+          </a:xfrm>
+          <a:prstGeom prst="rect">
+            <a:avLst/>
+          </a:prstGeom>
+          <a:noFill/>
+          <a:ln/>
+        </p:spPr>
+        <p:txBody>
+          <a:bodyPr wrap="square" lIns="0" tIns="0" rIns="0" bIns="0" rtlCol="0" anchor="ctr"/>
+          <a:lstStyle/>
+          <a:p>
+            <a:pPr indent="0" marL="0">
+              <a:buNone/>
+            </a:pPr>
+            <a:r>
+              <a:rPr lang="en-US" sz="1200" dirty="0">
                 <a:solidFill>
                   <a:srgbClr val="E9EEF3"/>
                 </a:solidFill>
@@ -4775,7 +5442,7 @@
               </a:rPr>
               <a:t>In-code governance allowlist</a:t>
             </a:r>
-            <a:endParaRPr lang="en-US" sz="1300" dirty="0"/>
+            <a:endParaRPr lang="en-US" sz="1200" dirty="0"/>
           </a:p>
         </p:txBody>
       </p:sp>
@@ -4787,8 +5454,8 @@
         </p:nvSpPr>
         <p:spPr>
           <a:xfrm>
-            <a:off x="5175504" y="4297680"/>
-            <a:ext cx="256032" cy="182880"/>
+            <a:off x="5175504" y="4005072"/>
+            <a:ext cx="256032" cy="146304"/>
           </a:xfrm>
           <a:prstGeom prst="rightArrow">
             <a:avLst/>
@@ -4807,12 +5474,12 @@
         </p:nvSpPr>
         <p:spPr>
           <a:xfrm>
-            <a:off x="5486400" y="4105656"/>
-            <a:ext cx="6080760" cy="566928"/>
+            <a:off x="5486400" y="3849624"/>
+            <a:ext cx="6080760" cy="457200"/>
           </a:xfrm>
           <a:prstGeom prst="roundRect">
             <a:avLst>
-              <a:gd name="adj" fmla="val 14516"/>
+              <a:gd name="adj" fmla="val 18000"/>
             </a:avLst>
           </a:prstGeom>
           <a:solidFill>
@@ -4841,24 +5508,24 @@
         </p:nvSpPr>
         <p:spPr>
           <a:xfrm>
-            <a:off x="5760720" y="4105656"/>
-            <a:ext cx="5623560" cy="566928"/>
-          </a:xfrm>
-          <a:prstGeom prst="rect">
-            <a:avLst/>
-          </a:prstGeom>
-          <a:noFill/>
-          <a:ln/>
-        </p:spPr>
-        <p:txBody>
-          <a:bodyPr wrap="square" lIns="0" tIns="0" rIns="0" bIns="0" rtlCol="0" anchor="ctr"/>
-          <a:lstStyle/>
-          <a:p>
-            <a:pPr indent="0" marL="0">
-              <a:buNone/>
-            </a:pPr>
-            <a:r>
-              <a:rPr lang="en-US" sz="1300" dirty="0">
+            <a:off x="5760720" y="3849624"/>
+            <a:ext cx="5623560" cy="457200"/>
+          </a:xfrm>
+          <a:prstGeom prst="rect">
+            <a:avLst/>
+          </a:prstGeom>
+          <a:noFill/>
+          <a:ln/>
+        </p:spPr>
+        <p:txBody>
+          <a:bodyPr wrap="square" lIns="0" tIns="0" rIns="0" bIns="0" rtlCol="0" anchor="ctr"/>
+          <a:lstStyle/>
+          <a:p>
+            <a:pPr indent="0" marL="0">
+              <a:buNone/>
+            </a:pPr>
+            <a:r>
+              <a:rPr lang="en-US" sz="1200" dirty="0">
                 <a:solidFill>
                   <a:srgbClr val="E9EEF3"/>
                 </a:solidFill>
@@ -4868,7 +5535,7 @@
               </a:rPr>
               <a:t>GRANT EXECUTE ON FUNCTION + row/column-level security</a:t>
             </a:r>
-            <a:endParaRPr lang="en-US" sz="1300" dirty="0"/>
+            <a:endParaRPr lang="en-US" sz="1200" dirty="0"/>
           </a:p>
         </p:txBody>
       </p:sp>
@@ -4880,12 +5547,12 @@
         </p:nvSpPr>
         <p:spPr>
           <a:xfrm>
-            <a:off x="640080" y="4764024"/>
-            <a:ext cx="4480560" cy="566928"/>
+            <a:off x="640080" y="4379976"/>
+            <a:ext cx="4480560" cy="457200"/>
           </a:xfrm>
           <a:prstGeom prst="roundRect">
             <a:avLst>
-              <a:gd name="adj" fmla="val 14516"/>
+              <a:gd name="adj" fmla="val 18000"/>
             </a:avLst>
           </a:prstGeom>
           <a:solidFill>
@@ -4914,24 +5581,24 @@
         </p:nvSpPr>
         <p:spPr>
           <a:xfrm>
-            <a:off x="914400" y="4764024"/>
-            <a:ext cx="4023360" cy="566928"/>
-          </a:xfrm>
-          <a:prstGeom prst="rect">
-            <a:avLst/>
-          </a:prstGeom>
-          <a:noFill/>
-          <a:ln/>
-        </p:spPr>
-        <p:txBody>
-          <a:bodyPr wrap="square" lIns="0" tIns="0" rIns="0" bIns="0" rtlCol="0" anchor="ctr"/>
-          <a:lstStyle/>
-          <a:p>
-            <a:pPr indent="0" marL="0">
-              <a:buNone/>
-            </a:pPr>
-            <a:r>
-              <a:rPr lang="en-US" sz="1300" dirty="0">
+            <a:off x="914400" y="4379976"/>
+            <a:ext cx="4023360" cy="457200"/>
+          </a:xfrm>
+          <a:prstGeom prst="rect">
+            <a:avLst/>
+          </a:prstGeom>
+          <a:noFill/>
+          <a:ln/>
+        </p:spPr>
+        <p:txBody>
+          <a:bodyPr wrap="square" lIns="0" tIns="0" rIns="0" bIns="0" rtlCol="0" anchor="ctr"/>
+          <a:lstStyle/>
+          <a:p>
+            <a:pPr indent="0" marL="0">
+              <a:buNone/>
+            </a:pPr>
+            <a:r>
+              <a:rPr lang="en-US" sz="1200" dirty="0">
                 <a:solidFill>
                   <a:srgbClr val="E9EEF3"/>
                 </a:solidFill>
@@ -4939,9 +5606,9 @@
                 <a:ea typeface="Calibri" pitchFamily="34" charset="-122"/>
                 <a:cs typeface="Calibri" pitchFamily="34" charset="-120"/>
               </a:rPr>
-              <a:t>Local deterministic planner</a:t>
-            </a:r>
-            <a:endParaRPr lang="en-US" sz="1300" dirty="0"/>
+              <a:t>Append-only audit log</a:t>
+            </a:r>
+            <a:endParaRPr lang="en-US" sz="1200" dirty="0"/>
           </a:p>
         </p:txBody>
       </p:sp>
@@ -4953,8 +5620,8 @@
         </p:nvSpPr>
         <p:spPr>
           <a:xfrm>
-            <a:off x="5175504" y="4956048"/>
-            <a:ext cx="256032" cy="182880"/>
+            <a:off x="5175504" y="4535424"/>
+            <a:ext cx="256032" cy="146304"/>
           </a:xfrm>
           <a:prstGeom prst="rightArrow">
             <a:avLst/>
@@ -4973,12 +5640,12 @@
         </p:nvSpPr>
         <p:spPr>
           <a:xfrm>
-            <a:off x="5486400" y="4764024"/>
-            <a:ext cx="6080760" cy="566928"/>
+            <a:off x="5486400" y="4379976"/>
+            <a:ext cx="6080760" cy="457200"/>
           </a:xfrm>
           <a:prstGeom prst="roundRect">
             <a:avLst>
-              <a:gd name="adj" fmla="val 14516"/>
+              <a:gd name="adj" fmla="val 18000"/>
             </a:avLst>
           </a:prstGeom>
           <a:solidFill>
@@ -5007,24 +5674,24 @@
         </p:nvSpPr>
         <p:spPr>
           <a:xfrm>
-            <a:off x="5760720" y="4764024"/>
-            <a:ext cx="5623560" cy="566928"/>
-          </a:xfrm>
-          <a:prstGeom prst="rect">
-            <a:avLst/>
-          </a:prstGeom>
-          <a:noFill/>
-          <a:ln/>
-        </p:spPr>
-        <p:txBody>
-          <a:bodyPr wrap="square" lIns="0" tIns="0" rIns="0" bIns="0" rtlCol="0" anchor="ctr"/>
-          <a:lstStyle/>
-          <a:p>
-            <a:pPr indent="0" marL="0">
-              <a:buNone/>
-            </a:pPr>
-            <a:r>
-              <a:rPr lang="en-US" sz="1300" dirty="0">
+            <a:off x="5760720" y="4379976"/>
+            <a:ext cx="5623560" cy="457200"/>
+          </a:xfrm>
+          <a:prstGeom prst="rect">
+            <a:avLst/>
+          </a:prstGeom>
+          <a:noFill/>
+          <a:ln/>
+        </p:spPr>
+        <p:txBody>
+          <a:bodyPr wrap="square" lIns="0" tIns="0" rIns="0" bIns="0" rtlCol="0" anchor="ctr"/>
+          <a:lstStyle/>
+          <a:p>
+            <a:pPr indent="0" marL="0">
+              <a:buNone/>
+            </a:pPr>
+            <a:r>
+              <a:rPr lang="en-US" sz="1200" dirty="0">
                 <a:solidFill>
                   <a:srgbClr val="E9EEF3"/>
                 </a:solidFill>
@@ -5032,9 +5699,9 @@
                 <a:ea typeface="Calibri" pitchFamily="34" charset="-122"/>
                 <a:cs typeface="Calibri" pitchFamily="34" charset="-120"/>
               </a:rPr>
-              <a:t>Databricks Model Serving (Llama 3 / DBRX) in your VPC</a:t>
-            </a:r>
-            <a:endParaRPr lang="en-US" sz="1300" dirty="0"/>
+              <a:t>Delta audit table with retention policy, or your SIEM</a:t>
+            </a:r>
+            <a:endParaRPr lang="en-US" sz="1200" dirty="0"/>
           </a:p>
         </p:txBody>
       </p:sp>
@@ -5046,12 +5713,12 @@
         </p:nvSpPr>
         <p:spPr>
           <a:xfrm>
-            <a:off x="640080" y="5422392"/>
-            <a:ext cx="4480560" cy="566928"/>
+            <a:off x="640080" y="4910328"/>
+            <a:ext cx="4480560" cy="457200"/>
           </a:xfrm>
           <a:prstGeom prst="roundRect">
             <a:avLst>
-              <a:gd name="adj" fmla="val 14516"/>
+              <a:gd name="adj" fmla="val 18000"/>
             </a:avLst>
           </a:prstGeom>
           <a:solidFill>
@@ -5080,24 +5747,24 @@
         </p:nvSpPr>
         <p:spPr>
           <a:xfrm>
-            <a:off x="914400" y="5422392"/>
-            <a:ext cx="4023360" cy="566928"/>
-          </a:xfrm>
-          <a:prstGeom prst="rect">
-            <a:avLst/>
-          </a:prstGeom>
-          <a:noFill/>
-          <a:ln/>
-        </p:spPr>
-        <p:txBody>
-          <a:bodyPr wrap="square" lIns="0" tIns="0" rIns="0" bIns="0" rtlCol="0" anchor="ctr"/>
-          <a:lstStyle/>
-          <a:p>
-            <a:pPr indent="0" marL="0">
-              <a:buNone/>
-            </a:pPr>
-            <a:r>
-              <a:rPr lang="en-US" sz="1300" dirty="0">
+            <a:off x="914400" y="4910328"/>
+            <a:ext cx="4023360" cy="457200"/>
+          </a:xfrm>
+          <a:prstGeom prst="rect">
+            <a:avLst/>
+          </a:prstGeom>
+          <a:noFill/>
+          <a:ln/>
+        </p:spPr>
+        <p:txBody>
+          <a:bodyPr wrap="square" lIns="0" tIns="0" rIns="0" bIns="0" rtlCol="0" anchor="ctr"/>
+          <a:lstStyle/>
+          <a:p>
+            <a:pPr indent="0" marL="0">
+              <a:buNone/>
+            </a:pPr>
+            <a:r>
+              <a:rPr lang="en-US" sz="1200" dirty="0">
                 <a:solidFill>
                   <a:srgbClr val="E9EEF3"/>
                 </a:solidFill>
@@ -5105,9 +5772,9 @@
                 <a:ea typeface="Calibri" pitchFamily="34" charset="-122"/>
                 <a:cs typeface="Calibri" pitchFamily="34" charset="-120"/>
               </a:rPr>
-              <a:t>Synthetic JSON generator</a:t>
-            </a:r>
-            <a:endParaRPr lang="en-US" sz="1300" dirty="0"/>
+              <a:t>Local deterministic planner</a:t>
+            </a:r>
+            <a:endParaRPr lang="en-US" sz="1200" dirty="0"/>
           </a:p>
         </p:txBody>
       </p:sp>
@@ -5119,8 +5786,8 @@
         </p:nvSpPr>
         <p:spPr>
           <a:xfrm>
-            <a:off x="5175504" y="5614416"/>
-            <a:ext cx="256032" cy="182880"/>
+            <a:off x="5175504" y="5065776"/>
+            <a:ext cx="256032" cy="146304"/>
           </a:xfrm>
           <a:prstGeom prst="rightArrow">
             <a:avLst/>
@@ -5139,12 +5806,12 @@
         </p:nvSpPr>
         <p:spPr>
           <a:xfrm>
-            <a:off x="5486400" y="5422392"/>
-            <a:ext cx="6080760" cy="566928"/>
+            <a:off x="5486400" y="4910328"/>
+            <a:ext cx="6080760" cy="457200"/>
           </a:xfrm>
           <a:prstGeom prst="roundRect">
             <a:avLst>
-              <a:gd name="adj" fmla="val 14516"/>
+              <a:gd name="adj" fmla="val 18000"/>
             </a:avLst>
           </a:prstGeom>
           <a:solidFill>
@@ -5173,24 +5840,24 @@
         </p:nvSpPr>
         <p:spPr>
           <a:xfrm>
-            <a:off x="5760720" y="5422392"/>
-            <a:ext cx="5623560" cy="566928"/>
-          </a:xfrm>
-          <a:prstGeom prst="rect">
-            <a:avLst/>
-          </a:prstGeom>
-          <a:noFill/>
-          <a:ln/>
-        </p:spPr>
-        <p:txBody>
-          <a:bodyPr wrap="square" lIns="0" tIns="0" rIns="0" bIns="0" rtlCol="0" anchor="ctr"/>
-          <a:lstStyle/>
-          <a:p>
-            <a:pPr indent="0" marL="0">
-              <a:buNone/>
-            </a:pPr>
-            <a:r>
-              <a:rPr lang="en-US" sz="1300" dirty="0">
+            <a:off x="5760720" y="4910328"/>
+            <a:ext cx="5623560" cy="457200"/>
+          </a:xfrm>
+          <a:prstGeom prst="rect">
+            <a:avLst/>
+          </a:prstGeom>
+          <a:noFill/>
+          <a:ln/>
+        </p:spPr>
+        <p:txBody>
+          <a:bodyPr wrap="square" lIns="0" tIns="0" rIns="0" bIns="0" rtlCol="0" anchor="ctr"/>
+          <a:lstStyle/>
+          <a:p>
+            <a:pPr indent="0" marL="0">
+              <a:buNone/>
+            </a:pPr>
+            <a:r>
+              <a:rPr lang="en-US" sz="1200" dirty="0">
                 <a:solidFill>
                   <a:srgbClr val="E9EEF3"/>
                 </a:solidFill>
@@ -5198,54 +5865,220 @@
                 <a:ea typeface="Calibri" pitchFamily="34" charset="-122"/>
                 <a:cs typeface="Calibri" pitchFamily="34" charset="-120"/>
               </a:rPr>
+              <a:t>Databricks Model Serving (Llama 3 / DBRX) in your VPC</a:t>
+            </a:r>
+            <a:endParaRPr lang="en-US" sz="1200" dirty="0"/>
+          </a:p>
+        </p:txBody>
+      </p:sp>
+      <p:sp>
+        <p:nvSpPr>
+          <p:cNvPr id="33" name="Shape 31"/>
+          <p:cNvSpPr/>
+          <p:nvPr/>
+        </p:nvSpPr>
+        <p:spPr>
+          <a:xfrm>
+            <a:off x="640080" y="5440680"/>
+            <a:ext cx="4480560" cy="457200"/>
+          </a:xfrm>
+          <a:prstGeom prst="roundRect">
+            <a:avLst>
+              <a:gd name="adj" fmla="val 18000"/>
+            </a:avLst>
+          </a:prstGeom>
+          <a:solidFill>
+            <a:srgbClr val="1F2C3A"/>
+          </a:solidFill>
+          <a:ln w="12700">
+            <a:solidFill>
+              <a:srgbClr val="2A3745"/>
+            </a:solidFill>
+            <a:prstDash val="solid"/>
+          </a:ln>
+          <a:effectLst>
+            <a:outerShdw sx="100000" sy="100000" kx="0" ky="0" algn="bl" rotWithShape="0" blurRad="114300" dist="38100" dir="5400000">
+              <a:srgbClr val="000000">
+                <a:alpha val="28000"/>
+              </a:srgbClr>
+            </a:outerShdw>
+          </a:effectLst>
+        </p:spPr>
+      </p:sp>
+      <p:sp>
+        <p:nvSpPr>
+          <p:cNvPr id="34" name="Text 32"/>
+          <p:cNvSpPr/>
+          <p:nvPr/>
+        </p:nvSpPr>
+        <p:spPr>
+          <a:xfrm>
+            <a:off x="914400" y="5440680"/>
+            <a:ext cx="4023360" cy="457200"/>
+          </a:xfrm>
+          <a:prstGeom prst="rect">
+            <a:avLst/>
+          </a:prstGeom>
+          <a:noFill/>
+          <a:ln/>
+        </p:spPr>
+        <p:txBody>
+          <a:bodyPr wrap="square" lIns="0" tIns="0" rIns="0" bIns="0" rtlCol="0" anchor="ctr"/>
+          <a:lstStyle/>
+          <a:p>
+            <a:pPr indent="0" marL="0">
+              <a:buNone/>
+            </a:pPr>
+            <a:r>
+              <a:rPr lang="en-US" sz="1200" dirty="0">
+                <a:solidFill>
+                  <a:srgbClr val="E9EEF3"/>
+                </a:solidFill>
+                <a:latin typeface="Calibri" pitchFamily="34" charset="0"/>
+                <a:ea typeface="Calibri" pitchFamily="34" charset="-122"/>
+                <a:cs typeface="Calibri" pitchFamily="34" charset="-120"/>
+              </a:rPr>
+              <a:t>Synthetic JSON generator</a:t>
+            </a:r>
+            <a:endParaRPr lang="en-US" sz="1200" dirty="0"/>
+          </a:p>
+        </p:txBody>
+      </p:sp>
+      <p:sp>
+        <p:nvSpPr>
+          <p:cNvPr id="35" name="Shape 33"/>
+          <p:cNvSpPr/>
+          <p:nvPr/>
+        </p:nvSpPr>
+        <p:spPr>
+          <a:xfrm>
+            <a:off x="5175504" y="5596128"/>
+            <a:ext cx="256032" cy="146304"/>
+          </a:xfrm>
+          <a:prstGeom prst="rightArrow">
+            <a:avLst/>
+          </a:prstGeom>
+          <a:solidFill>
+            <a:srgbClr val="FF6C00"/>
+          </a:solidFill>
+          <a:ln/>
+        </p:spPr>
+      </p:sp>
+      <p:sp>
+        <p:nvSpPr>
+          <p:cNvPr id="36" name="Shape 34"/>
+          <p:cNvSpPr/>
+          <p:nvPr/>
+        </p:nvSpPr>
+        <p:spPr>
+          <a:xfrm>
+            <a:off x="5486400" y="5440680"/>
+            <a:ext cx="6080760" cy="457200"/>
+          </a:xfrm>
+          <a:prstGeom prst="roundRect">
+            <a:avLst>
+              <a:gd name="adj" fmla="val 18000"/>
+            </a:avLst>
+          </a:prstGeom>
+          <a:solidFill>
+            <a:srgbClr val="1F2C3A"/>
+          </a:solidFill>
+          <a:ln w="12700">
+            <a:solidFill>
+              <a:srgbClr val="2A3745"/>
+            </a:solidFill>
+            <a:prstDash val="solid"/>
+          </a:ln>
+          <a:effectLst>
+            <a:outerShdw sx="100000" sy="100000" kx="0" ky="0" algn="bl" rotWithShape="0" blurRad="114300" dist="38100" dir="5400000">
+              <a:srgbClr val="000000">
+                <a:alpha val="28000"/>
+              </a:srgbClr>
+            </a:outerShdw>
+          </a:effectLst>
+        </p:spPr>
+      </p:sp>
+      <p:sp>
+        <p:nvSpPr>
+          <p:cNvPr id="37" name="Text 35"/>
+          <p:cNvSpPr/>
+          <p:nvPr/>
+        </p:nvSpPr>
+        <p:spPr>
+          <a:xfrm>
+            <a:off x="5760720" y="5440680"/>
+            <a:ext cx="5623560" cy="457200"/>
+          </a:xfrm>
+          <a:prstGeom prst="rect">
+            <a:avLst/>
+          </a:prstGeom>
+          <a:noFill/>
+          <a:ln/>
+        </p:spPr>
+        <p:txBody>
+          <a:bodyPr wrap="square" lIns="0" tIns="0" rIns="0" bIns="0" rtlCol="0" anchor="ctr"/>
+          <a:lstStyle/>
+          <a:p>
+            <a:pPr indent="0" marL="0">
+              <a:buNone/>
+            </a:pPr>
+            <a:r>
+              <a:rPr lang="en-US" sz="1200" dirty="0">
+                <a:solidFill>
+                  <a:srgbClr val="E9EEF3"/>
+                </a:solidFill>
+                <a:latin typeface="Calibri" pitchFamily="34" charset="0"/>
+                <a:ea typeface="Calibri" pitchFamily="34" charset="-122"/>
+                <a:cs typeface="Calibri" pitchFamily="34" charset="-120"/>
+              </a:rPr>
               <a:t>Kafka streams / cloud storage via Auto Loader</a:t>
             </a:r>
+            <a:endParaRPr lang="en-US" sz="1200" dirty="0"/>
+          </a:p>
+        </p:txBody>
+      </p:sp>
+      <p:sp>
+        <p:nvSpPr>
+          <p:cNvPr id="38" name="Text 36"/>
+          <p:cNvSpPr/>
+          <p:nvPr/>
+        </p:nvSpPr>
+        <p:spPr>
+          <a:xfrm>
+            <a:off x="640080" y="6053328"/>
+            <a:ext cx="10881360" cy="274320"/>
+          </a:xfrm>
+          <a:prstGeom prst="rect">
+            <a:avLst/>
+          </a:prstGeom>
+          <a:noFill/>
+          <a:ln/>
+        </p:spPr>
+        <p:txBody>
+          <a:bodyPr wrap="square" lIns="0" tIns="0" rIns="0" bIns="0" rtlCol="0" anchor="ctr"/>
+          <a:lstStyle/>
+          <a:p>
+            <a:pPr indent="0" marL="0">
+              <a:buNone/>
+            </a:pPr>
+            <a:r>
+              <a:rPr lang="en-US" sz="1300" i="1" dirty="0">
+                <a:solidFill>
+                  <a:srgbClr val="93A1AF"/>
+                </a:solidFill>
+                <a:latin typeface="Calibri" pitchFamily="34" charset="0"/>
+                <a:ea typeface="Calibri" pitchFamily="34" charset="-122"/>
+                <a:cs typeface="Calibri" pitchFamily="34" charset="-120"/>
+              </a:rPr>
+              <a:t>Point DATABRICKS_HOST / DATABRICKS_TOKEN at a workspace and the same call path routes to the served model.</a:t>
+            </a:r>
             <a:endParaRPr lang="en-US" sz="1300" dirty="0"/>
           </a:p>
         </p:txBody>
       </p:sp>
       <p:sp>
         <p:nvSpPr>
-          <p:cNvPr id="33" name="Text 31"/>
-          <p:cNvSpPr/>
-          <p:nvPr/>
-        </p:nvSpPr>
-        <p:spPr>
-          <a:xfrm>
-            <a:off x="640080" y="6172200"/>
-            <a:ext cx="10881360" cy="365760"/>
-          </a:xfrm>
-          <a:prstGeom prst="rect">
-            <a:avLst/>
-          </a:prstGeom>
-          <a:noFill/>
-          <a:ln/>
-        </p:spPr>
-        <p:txBody>
-          <a:bodyPr wrap="square" lIns="0" tIns="0" rIns="0" bIns="0" rtlCol="0" anchor="ctr"/>
-          <a:lstStyle/>
-          <a:p>
-            <a:pPr indent="0" marL="0">
-              <a:buNone/>
-            </a:pPr>
-            <a:r>
-              <a:rPr lang="en-US" sz="1300" i="1" dirty="0">
-                <a:solidFill>
-                  <a:srgbClr val="93A1AF"/>
-                </a:solidFill>
-                <a:latin typeface="Calibri" pitchFamily="34" charset="0"/>
-                <a:ea typeface="Calibri" pitchFamily="34" charset="-122"/>
-                <a:cs typeface="Calibri" pitchFamily="34" charset="-120"/>
-              </a:rPr>
-              <a:t>Point DATABRICKS_HOST / DATABRICKS_TOKEN at a workspace and the same call path routes to the served model.</a:t>
-            </a:r>
-            <a:endParaRPr lang="en-US" sz="1300" dirty="0"/>
-          </a:p>
-        </p:txBody>
-      </p:sp>
-      <p:sp>
-        <p:nvSpPr>
-          <p:cNvPr id="34" name="Text 32"/>
+          <p:cNvPr id="39" name="Text 37"/>
           <p:cNvSpPr/>
           <p:nvPr/>
         </p:nvSpPr>
@@ -5276,7 +6109,7 @@
                 <a:ea typeface="Calibri" pitchFamily="34" charset="-122"/>
                 <a:cs typeface="Calibri" pitchFamily="34" charset="-120"/>
               </a:rPr>
-              <a:t>12</a:t>
+              <a:t>13</a:t>
             </a:r>
             <a:endParaRPr lang="en-US" sz="1000" dirty="0"/>
           </a:p>
@@ -5284,7 +6117,7 @@
       </p:sp>
       <p:sp>
         <p:nvSpPr>
-          <p:cNvPr id="35" name="Text 33"/>
+          <p:cNvPr id="40" name="Text 38"/>
           <p:cNvSpPr/>
           <p:nvPr/>
         </p:nvSpPr>
@@ -5329,9 +6162,9 @@
 </p:sld>
 </file>
 
-<file path=ppt/slides/slide13.xml><?xml version="1.0" encoding="utf-8"?>
+<file path=ppt/slides/slide14.xml><?xml version="1.0" encoding="utf-8"?>
 <p:sld xmlns:a="http://schemas.openxmlformats.org/drawingml/2006/main" xmlns:r="http://schemas.openxmlformats.org/officeDocument/2006/relationships" xmlns:p="http://schemas.openxmlformats.org/presentationml/2006/main">
-  <p:cSld name="Slide 13">
+  <p:cSld name="Slide 14">
     <p:bg>
       <p:bgPr>
         <a:solidFill>
@@ -5556,7 +6389,7 @@
                 <a:ea typeface="Calibri" pitchFamily="34" charset="-122"/>
                 <a:cs typeface="Calibri" pitchFamily="34" charset="-120"/>
               </a:rPr>
-              <a:t>IntelligenceStack proves it with running code — real answers, cited guidance, an enforced boundary, and a clean path to production.</a:t>
+              <a:t>IntelligenceStack proves it with running code — real answers, cited guidance, an enforced boundary, and a durable record of every decision.</a:t>
             </a:r>
             <a:endParaRPr lang="en-US" sz="1700" dirty="0"/>
           </a:p>
@@ -7575,7 +8408,7 @@
                 <a:ea typeface="Calibri" pitchFamily="34" charset="-122"/>
                 <a:cs typeface="Calibri" pitchFamily="34" charset="-120"/>
               </a:rPr>
-              <a:t>Compliance answer: here is the allowlist</a:t>
+              <a:t>Compliance answer: here is the evidence</a:t>
             </a:r>
             <a:endParaRPr lang="en-US" sz="1400" dirty="0"/>
           </a:p>
@@ -7861,7 +8694,7 @@
         <p:spPr>
           <a:xfrm>
             <a:off x="5760720" y="1828800"/>
-            <a:ext cx="365760" cy="365760"/>
+            <a:ext cx="329184" cy="329184"/>
           </a:xfrm>
           <a:prstGeom prst="ellipse">
             <a:avLst/>
@@ -7886,7 +8719,7 @@
         <p:spPr>
           <a:xfrm>
             <a:off x="5760720" y="1828800"/>
-            <a:ext cx="365760" cy="365760"/>
+            <a:ext cx="329184" cy="329184"/>
           </a:xfrm>
           <a:prstGeom prst="rect">
             <a:avLst/>
@@ -7902,7 +8735,7 @@
               <a:buNone/>
             </a:pPr>
             <a:r>
-              <a:rPr lang="en-US" sz="1500" b="1" dirty="0">
+              <a:rPr lang="en-US" sz="1400" b="1" dirty="0">
                 <a:solidFill>
                   <a:srgbClr val="FF8A3D"/>
                 </a:solidFill>
@@ -7912,7 +8745,7 @@
               </a:rPr>
               <a:t>1</a:t>
             </a:r>
-            <a:endParaRPr lang="en-US" sz="1500" dirty="0"/>
+            <a:endParaRPr lang="en-US" sz="1400" dirty="0"/>
           </a:p>
         </p:txBody>
       </p:sp>
@@ -7924,24 +8757,24 @@
         </p:nvSpPr>
         <p:spPr>
           <a:xfrm>
-            <a:off x="6291072" y="1755648"/>
-            <a:ext cx="5230368" cy="329184"/>
-          </a:xfrm>
-          <a:prstGeom prst="rect">
-            <a:avLst/>
-          </a:prstGeom>
-          <a:noFill/>
-          <a:ln/>
-        </p:spPr>
-        <p:txBody>
-          <a:bodyPr wrap="square" lIns="0" tIns="0" rIns="0" bIns="0" rtlCol="0" anchor="ctr"/>
-          <a:lstStyle/>
-          <a:p>
-            <a:pPr indent="0" marL="0">
-              <a:buNone/>
-            </a:pPr>
-            <a:r>
-              <a:rPr lang="en-US" sz="1500" b="1" dirty="0">
+            <a:off x="6236208" y="1764792"/>
+            <a:ext cx="5285232" cy="292608"/>
+          </a:xfrm>
+          <a:prstGeom prst="rect">
+            <a:avLst/>
+          </a:prstGeom>
+          <a:noFill/>
+          <a:ln/>
+        </p:spPr>
+        <p:txBody>
+          <a:bodyPr wrap="square" lIns="0" tIns="0" rIns="0" bIns="0" rtlCol="0" anchor="ctr"/>
+          <a:lstStyle/>
+          <a:p>
+            <a:pPr indent="0" marL="0">
+              <a:buNone/>
+            </a:pPr>
+            <a:r>
+              <a:rPr lang="en-US" sz="1400" b="1" dirty="0">
                 <a:solidFill>
                   <a:srgbClr val="E9EEF3"/>
                 </a:solidFill>
@@ -7951,7 +8784,7 @@
               </a:rPr>
               <a:t>Streaming ingestion</a:t>
             </a:r>
-            <a:endParaRPr lang="en-US" sz="1500" dirty="0"/>
+            <a:endParaRPr lang="en-US" sz="1400" dirty="0"/>
           </a:p>
         </p:txBody>
       </p:sp>
@@ -7963,8 +8796,8 @@
         </p:nvSpPr>
         <p:spPr>
           <a:xfrm>
-            <a:off x="6291072" y="2066544"/>
-            <a:ext cx="5230368" cy="640080"/>
+            <a:off x="6236208" y="2039112"/>
+            <a:ext cx="5285232" cy="530352"/>
           </a:xfrm>
           <a:prstGeom prst="rect">
             <a:avLst/>
@@ -7978,12 +8811,12 @@
           <a:p>
             <a:pPr indent="0" marL="0">
               <a:lnSpc>
-                <a:spcPct val="105000"/>
+                <a:spcPct val="102000"/>
               </a:lnSpc>
               <a:buNone/>
             </a:pPr>
             <a:r>
-              <a:rPr lang="en-US" sz="1150" dirty="0">
+              <a:rPr lang="en-US" sz="1050" dirty="0">
                 <a:solidFill>
                   <a:srgbClr val="93A1AF"/>
                 </a:solidFill>
@@ -7993,7 +8826,7 @@
               </a:rPr>
               <a:t>Auto Loader + Delta Live Tables land events through a bronze → silver → gold medallion, enforcing data quality and hashing PII on the way in.</a:t>
             </a:r>
-            <a:endParaRPr lang="en-US" sz="1150" dirty="0"/>
+            <a:endParaRPr lang="en-US" sz="1050" dirty="0"/>
           </a:p>
         </p:txBody>
       </p:sp>
@@ -8005,8 +8838,8 @@
         </p:nvSpPr>
         <p:spPr>
           <a:xfrm>
-            <a:off x="5760720" y="2715768"/>
-            <a:ext cx="365760" cy="365760"/>
+            <a:off x="5760720" y="2569464"/>
+            <a:ext cx="329184" cy="329184"/>
           </a:xfrm>
           <a:prstGeom prst="ellipse">
             <a:avLst/>
@@ -8030,8 +8863,8 @@
         </p:nvSpPr>
         <p:spPr>
           <a:xfrm>
-            <a:off x="5760720" y="2715768"/>
-            <a:ext cx="365760" cy="365760"/>
+            <a:off x="5760720" y="2569464"/>
+            <a:ext cx="329184" cy="329184"/>
           </a:xfrm>
           <a:prstGeom prst="rect">
             <a:avLst/>
@@ -8047,7 +8880,7 @@
               <a:buNone/>
             </a:pPr>
             <a:r>
-              <a:rPr lang="en-US" sz="1500" b="1" dirty="0">
+              <a:rPr lang="en-US" sz="1400" b="1" dirty="0">
                 <a:solidFill>
                   <a:srgbClr val="FF8A3D"/>
                 </a:solidFill>
@@ -8057,7 +8890,7 @@
               </a:rPr>
               <a:t>2</a:t>
             </a:r>
-            <a:endParaRPr lang="en-US" sz="1500" dirty="0"/>
+            <a:endParaRPr lang="en-US" sz="1400" dirty="0"/>
           </a:p>
         </p:txBody>
       </p:sp>
@@ -8069,24 +8902,24 @@
         </p:nvSpPr>
         <p:spPr>
           <a:xfrm>
-            <a:off x="6291072" y="2642616"/>
-            <a:ext cx="5230368" cy="329184"/>
-          </a:xfrm>
-          <a:prstGeom prst="rect">
-            <a:avLst/>
-          </a:prstGeom>
-          <a:noFill/>
-          <a:ln/>
-        </p:spPr>
-        <p:txBody>
-          <a:bodyPr wrap="square" lIns="0" tIns="0" rIns="0" bIns="0" rtlCol="0" anchor="ctr"/>
-          <a:lstStyle/>
-          <a:p>
-            <a:pPr indent="0" marL="0">
-              <a:buNone/>
-            </a:pPr>
-            <a:r>
-              <a:rPr lang="en-US" sz="1500" b="1" dirty="0">
+            <a:off x="6236208" y="2505456"/>
+            <a:ext cx="5285232" cy="292608"/>
+          </a:xfrm>
+          <a:prstGeom prst="rect">
+            <a:avLst/>
+          </a:prstGeom>
+          <a:noFill/>
+          <a:ln/>
+        </p:spPr>
+        <p:txBody>
+          <a:bodyPr wrap="square" lIns="0" tIns="0" rIns="0" bIns="0" rtlCol="0" anchor="ctr"/>
+          <a:lstStyle/>
+          <a:p>
+            <a:pPr indent="0" marL="0">
+              <a:buNone/>
+            </a:pPr>
+            <a:r>
+              <a:rPr lang="en-US" sz="1400" b="1" dirty="0">
                 <a:solidFill>
                   <a:srgbClr val="E9EEF3"/>
                 </a:solidFill>
@@ -8096,7 +8929,7 @@
               </a:rPr>
               <a:t>Governed gold layer</a:t>
             </a:r>
-            <a:endParaRPr lang="en-US" sz="1500" dirty="0"/>
+            <a:endParaRPr lang="en-US" sz="1400" dirty="0"/>
           </a:p>
         </p:txBody>
       </p:sp>
@@ -8108,8 +8941,8 @@
         </p:nvSpPr>
         <p:spPr>
           <a:xfrm>
-            <a:off x="6291072" y="2953512"/>
-            <a:ext cx="5230368" cy="640080"/>
+            <a:off x="6236208" y="2779776"/>
+            <a:ext cx="5285232" cy="530352"/>
           </a:xfrm>
           <a:prstGeom prst="rect">
             <a:avLst/>
@@ -8123,12 +8956,12 @@
           <a:p>
             <a:pPr indent="0" marL="0">
               <a:lnSpc>
-                <a:spcPct val="105000"/>
+                <a:spcPct val="102000"/>
               </a:lnSpc>
               <a:buNone/>
             </a:pPr>
             <a:r>
-              <a:rPr lang="en-US" sz="1150" dirty="0">
+              <a:rPr lang="en-US" sz="1050" dirty="0">
                 <a:solidFill>
                   <a:srgbClr val="93A1AF"/>
                 </a:solidFill>
@@ -8136,9 +8969,9 @@
                 <a:ea typeface="Calibri" pitchFamily="34" charset="-122"/>
                 <a:cs typeface="Calibri" pitchFamily="34" charset="-120"/>
               </a:rPr>
-              <a:t>Business-ready tables the agent reads. In the sandbox this is a real DuckDB engine; in production, a Serverless SQL Warehouse over Delta.</a:t>
-            </a:r>
-            <a:endParaRPr lang="en-US" sz="1150" dirty="0"/>
+              <a:t>Business-ready tables the agent reads. In the sandbox a real DuckDB engine; in production, a Serverless SQL Warehouse over Delta.</a:t>
+            </a:r>
+            <a:endParaRPr lang="en-US" sz="1050" dirty="0"/>
           </a:p>
         </p:txBody>
       </p:sp>
@@ -8150,8 +8983,8 @@
         </p:nvSpPr>
         <p:spPr>
           <a:xfrm>
-            <a:off x="5760720" y="3602736"/>
-            <a:ext cx="365760" cy="365760"/>
+            <a:off x="5760720" y="3310128"/>
+            <a:ext cx="329184" cy="329184"/>
           </a:xfrm>
           <a:prstGeom prst="ellipse">
             <a:avLst/>
@@ -8175,8 +9008,8 @@
         </p:nvSpPr>
         <p:spPr>
           <a:xfrm>
-            <a:off x="5760720" y="3602736"/>
-            <a:ext cx="365760" cy="365760"/>
+            <a:off x="5760720" y="3310128"/>
+            <a:ext cx="329184" cy="329184"/>
           </a:xfrm>
           <a:prstGeom prst="rect">
             <a:avLst/>
@@ -8192,7 +9025,7 @@
               <a:buNone/>
             </a:pPr>
             <a:r>
-              <a:rPr lang="en-US" sz="1500" b="1" dirty="0">
+              <a:rPr lang="en-US" sz="1400" b="1" dirty="0">
                 <a:solidFill>
                   <a:srgbClr val="FF8A3D"/>
                 </a:solidFill>
@@ -8202,7 +9035,7 @@
               </a:rPr>
               <a:t>3</a:t>
             </a:r>
-            <a:endParaRPr lang="en-US" sz="1500" dirty="0"/>
+            <a:endParaRPr lang="en-US" sz="1400" dirty="0"/>
           </a:p>
         </p:txBody>
       </p:sp>
@@ -8214,24 +9047,24 @@
         </p:nvSpPr>
         <p:spPr>
           <a:xfrm>
-            <a:off x="6291072" y="3529584"/>
-            <a:ext cx="5230368" cy="329184"/>
-          </a:xfrm>
-          <a:prstGeom prst="rect">
-            <a:avLst/>
-          </a:prstGeom>
-          <a:noFill/>
-          <a:ln/>
-        </p:spPr>
-        <p:txBody>
-          <a:bodyPr wrap="square" lIns="0" tIns="0" rIns="0" bIns="0" rtlCol="0" anchor="ctr"/>
-          <a:lstStyle/>
-          <a:p>
-            <a:pPr indent="0" marL="0">
-              <a:buNone/>
-            </a:pPr>
-            <a:r>
-              <a:rPr lang="en-US" sz="1500" b="1" dirty="0">
+            <a:off x="6236208" y="3246120"/>
+            <a:ext cx="5285232" cy="292608"/>
+          </a:xfrm>
+          <a:prstGeom prst="rect">
+            <a:avLst/>
+          </a:prstGeom>
+          <a:noFill/>
+          <a:ln/>
+        </p:spPr>
+        <p:txBody>
+          <a:bodyPr wrap="square" lIns="0" tIns="0" rIns="0" bIns="0" rtlCol="0" anchor="ctr"/>
+          <a:lstStyle/>
+          <a:p>
+            <a:pPr indent="0" marL="0">
+              <a:buNone/>
+            </a:pPr>
+            <a:r>
+              <a:rPr lang="en-US" sz="1400" b="1" dirty="0">
                 <a:solidFill>
                   <a:srgbClr val="E9EEF3"/>
                 </a:solidFill>
@@ -8241,7 +9074,7 @@
               </a:rPr>
               <a:t>Unity Catalog boundary</a:t>
             </a:r>
-            <a:endParaRPr lang="en-US" sz="1500" dirty="0"/>
+            <a:endParaRPr lang="en-US" sz="1400" dirty="0"/>
           </a:p>
         </p:txBody>
       </p:sp>
@@ -8253,8 +9086,8 @@
         </p:nvSpPr>
         <p:spPr>
           <a:xfrm>
-            <a:off x="6291072" y="3840480"/>
-            <a:ext cx="5230368" cy="640080"/>
+            <a:off x="6236208" y="3520440"/>
+            <a:ext cx="5285232" cy="530352"/>
           </a:xfrm>
           <a:prstGeom prst="rect">
             <a:avLst/>
@@ -8268,12 +9101,12 @@
           <a:p>
             <a:pPr indent="0" marL="0">
               <a:lnSpc>
-                <a:spcPct val="105000"/>
+                <a:spcPct val="102000"/>
               </a:lnSpc>
               <a:buNone/>
             </a:pPr>
             <a:r>
-              <a:rPr lang="en-US" sz="1150" dirty="0">
+              <a:rPr lang="en-US" sz="1050" dirty="0">
                 <a:solidFill>
                   <a:srgbClr val="93A1AF"/>
                 </a:solidFill>
@@ -8283,7 +9116,7 @@
               </a:rPr>
               <a:t>The agent is granted EXECUTE on a short allowlist of functions — never raw table access. Every call is checked before it runs.</a:t>
             </a:r>
-            <a:endParaRPr lang="en-US" sz="1150" dirty="0"/>
+            <a:endParaRPr lang="en-US" sz="1050" dirty="0"/>
           </a:p>
         </p:txBody>
       </p:sp>
@@ -8295,8 +9128,8 @@
         </p:nvSpPr>
         <p:spPr>
           <a:xfrm>
-            <a:off x="5760720" y="4489704"/>
-            <a:ext cx="365760" cy="365760"/>
+            <a:off x="5760720" y="4050792"/>
+            <a:ext cx="329184" cy="329184"/>
           </a:xfrm>
           <a:prstGeom prst="ellipse">
             <a:avLst/>
@@ -8320,8 +9153,8 @@
         </p:nvSpPr>
         <p:spPr>
           <a:xfrm>
-            <a:off x="5760720" y="4489704"/>
-            <a:ext cx="365760" cy="365760"/>
+            <a:off x="5760720" y="4050792"/>
+            <a:ext cx="329184" cy="329184"/>
           </a:xfrm>
           <a:prstGeom prst="rect">
             <a:avLst/>
@@ -8337,7 +9170,7 @@
               <a:buNone/>
             </a:pPr>
             <a:r>
-              <a:rPr lang="en-US" sz="1500" b="1" dirty="0">
+              <a:rPr lang="en-US" sz="1400" b="1" dirty="0">
                 <a:solidFill>
                   <a:srgbClr val="FF8A3D"/>
                 </a:solidFill>
@@ -8347,7 +9180,7 @@
               </a:rPr>
               <a:t>4</a:t>
             </a:r>
-            <a:endParaRPr lang="en-US" sz="1500" dirty="0"/>
+            <a:endParaRPr lang="en-US" sz="1400" dirty="0"/>
           </a:p>
         </p:txBody>
       </p:sp>
@@ -8359,24 +9192,24 @@
         </p:nvSpPr>
         <p:spPr>
           <a:xfrm>
-            <a:off x="6291072" y="4416552"/>
-            <a:ext cx="5230368" cy="329184"/>
-          </a:xfrm>
-          <a:prstGeom prst="rect">
-            <a:avLst/>
-          </a:prstGeom>
-          <a:noFill/>
-          <a:ln/>
-        </p:spPr>
-        <p:txBody>
-          <a:bodyPr wrap="square" lIns="0" tIns="0" rIns="0" bIns="0" rtlCol="0" anchor="ctr"/>
-          <a:lstStyle/>
-          <a:p>
-            <a:pPr indent="0" marL="0">
-              <a:buNone/>
-            </a:pPr>
-            <a:r>
-              <a:rPr lang="en-US" sz="1500" b="1" dirty="0">
+            <a:off x="6236208" y="3986784"/>
+            <a:ext cx="5285232" cy="292608"/>
+          </a:xfrm>
+          <a:prstGeom prst="rect">
+            <a:avLst/>
+          </a:prstGeom>
+          <a:noFill/>
+          <a:ln/>
+        </p:spPr>
+        <p:txBody>
+          <a:bodyPr wrap="square" lIns="0" tIns="0" rIns="0" bIns="0" rtlCol="0" anchor="ctr"/>
+          <a:lstStyle/>
+          <a:p>
+            <a:pPr indent="0" marL="0">
+              <a:buNone/>
+            </a:pPr>
+            <a:r>
+              <a:rPr lang="en-US" sz="1400" b="1" dirty="0">
                 <a:solidFill>
                   <a:srgbClr val="E9EEF3"/>
                 </a:solidFill>
@@ -8386,7 +9219,7 @@
               </a:rPr>
               <a:t>Mosaic AI Vector Search</a:t>
             </a:r>
-            <a:endParaRPr lang="en-US" sz="1500" dirty="0"/>
+            <a:endParaRPr lang="en-US" sz="1400" dirty="0"/>
           </a:p>
         </p:txBody>
       </p:sp>
@@ -8398,8 +9231,8 @@
         </p:nvSpPr>
         <p:spPr>
           <a:xfrm>
-            <a:off x="6291072" y="4727448"/>
-            <a:ext cx="5230368" cy="640080"/>
+            <a:off x="6236208" y="4261104"/>
+            <a:ext cx="5285232" cy="530352"/>
           </a:xfrm>
           <a:prstGeom prst="rect">
             <a:avLst/>
@@ -8413,12 +9246,12 @@
           <a:p>
             <a:pPr indent="0" marL="0">
               <a:lnSpc>
-                <a:spcPct val="105000"/>
+                <a:spcPct val="102000"/>
               </a:lnSpc>
               <a:buNone/>
             </a:pPr>
             <a:r>
-              <a:rPr lang="en-US" sz="1150" dirty="0">
+              <a:rPr lang="en-US" sz="1050" dirty="0">
                 <a:solidFill>
                   <a:srgbClr val="93A1AF"/>
                 </a:solidFill>
@@ -8426,9 +9259,9 @@
                 <a:ea typeface="Calibri" pitchFamily="34" charset="-122"/>
                 <a:cs typeface="Calibri" pitchFamily="34" charset="-120"/>
               </a:rPr>
-              <a:t>A governed index over enterprise runbooks and policies, so the agent can ground answers in documented knowledge as well as live metrics.</a:t>
-            </a:r>
-            <a:endParaRPr lang="en-US" sz="1150" dirty="0"/>
+              <a:t>A governed index over enterprise runbooks and policies, so answers can be grounded in documented knowledge as well as live metrics.</a:t>
+            </a:r>
+            <a:endParaRPr lang="en-US" sz="1050" dirty="0"/>
           </a:p>
         </p:txBody>
       </p:sp>
@@ -8440,8 +9273,8 @@
         </p:nvSpPr>
         <p:spPr>
           <a:xfrm>
-            <a:off x="5760720" y="5376672"/>
-            <a:ext cx="365760" cy="365760"/>
+            <a:off x="5760720" y="4791456"/>
+            <a:ext cx="329184" cy="329184"/>
           </a:xfrm>
           <a:prstGeom prst="ellipse">
             <a:avLst/>
@@ -8465,8 +9298,8 @@
         </p:nvSpPr>
         <p:spPr>
           <a:xfrm>
-            <a:off x="5760720" y="5376672"/>
-            <a:ext cx="365760" cy="365760"/>
+            <a:off x="5760720" y="4791456"/>
+            <a:ext cx="329184" cy="329184"/>
           </a:xfrm>
           <a:prstGeom prst="rect">
             <a:avLst/>
@@ -8482,7 +9315,7 @@
               <a:buNone/>
             </a:pPr>
             <a:r>
-              <a:rPr lang="en-US" sz="1500" b="1" dirty="0">
+              <a:rPr lang="en-US" sz="1400" b="1" dirty="0">
                 <a:solidFill>
                   <a:srgbClr val="FF8A3D"/>
                 </a:solidFill>
@@ -8492,7 +9325,7 @@
               </a:rPr>
               <a:t>5</a:t>
             </a:r>
-            <a:endParaRPr lang="en-US" sz="1500" dirty="0"/>
+            <a:endParaRPr lang="en-US" sz="1400" dirty="0"/>
           </a:p>
         </p:txBody>
       </p:sp>
@@ -8504,24 +9337,24 @@
         </p:nvSpPr>
         <p:spPr>
           <a:xfrm>
-            <a:off x="6291072" y="5303520"/>
-            <a:ext cx="5230368" cy="329184"/>
-          </a:xfrm>
-          <a:prstGeom prst="rect">
-            <a:avLst/>
-          </a:prstGeom>
-          <a:noFill/>
-          <a:ln/>
-        </p:spPr>
-        <p:txBody>
-          <a:bodyPr wrap="square" lIns="0" tIns="0" rIns="0" bIns="0" rtlCol="0" anchor="ctr"/>
-          <a:lstStyle/>
-          <a:p>
-            <a:pPr indent="0" marL="0">
-              <a:buNone/>
-            </a:pPr>
-            <a:r>
-              <a:rPr lang="en-US" sz="1500" b="1" dirty="0">
+            <a:off x="6236208" y="4727448"/>
+            <a:ext cx="5285232" cy="292608"/>
+          </a:xfrm>
+          <a:prstGeom prst="rect">
+            <a:avLst/>
+          </a:prstGeom>
+          <a:noFill/>
+          <a:ln/>
+        </p:spPr>
+        <p:txBody>
+          <a:bodyPr wrap="square" lIns="0" tIns="0" rIns="0" bIns="0" rtlCol="0" anchor="ctr"/>
+          <a:lstStyle/>
+          <a:p>
+            <a:pPr indent="0" marL="0">
+              <a:buNone/>
+            </a:pPr>
+            <a:r>
+              <a:rPr lang="en-US" sz="1400" b="1" dirty="0">
                 <a:solidFill>
                   <a:srgbClr val="E9EEF3"/>
                 </a:solidFill>
@@ -8529,22 +9362,167 @@
                 <a:ea typeface="Calibri" pitchFamily="34" charset="-122"/>
                 <a:cs typeface="Calibri" pitchFamily="34" charset="-120"/>
               </a:rPr>
+              <a:t>Audit trail</a:t>
+            </a:r>
+            <a:endParaRPr lang="en-US" sz="1400" dirty="0"/>
+          </a:p>
+        </p:txBody>
+      </p:sp>
+      <p:sp>
+        <p:nvSpPr>
+          <p:cNvPr id="25" name="Text 22"/>
+          <p:cNvSpPr/>
+          <p:nvPr/>
+        </p:nvSpPr>
+        <p:spPr>
+          <a:xfrm>
+            <a:off x="6236208" y="5001768"/>
+            <a:ext cx="5285232" cy="530352"/>
+          </a:xfrm>
+          <a:prstGeom prst="rect">
+            <a:avLst/>
+          </a:prstGeom>
+          <a:noFill/>
+          <a:ln/>
+        </p:spPr>
+        <p:txBody>
+          <a:bodyPr wrap="square" lIns="0" tIns="0" rIns="0" bIns="0" rtlCol="0" anchor="ctr"/>
+          <a:lstStyle/>
+          <a:p>
+            <a:pPr indent="0" marL="0">
+              <a:lnSpc>
+                <a:spcPct val="102000"/>
+              </a:lnSpc>
+              <a:buNone/>
+            </a:pPr>
+            <a:r>
+              <a:rPr lang="en-US" sz="1050" dirty="0">
+                <a:solidFill>
+                  <a:srgbClr val="93A1AF"/>
+                </a:solidFill>
+                <a:latin typeface="Calibri" pitchFamily="34" charset="0"/>
+                <a:ea typeface="Calibri" pitchFamily="34" charset="-122"/>
+                <a:cs typeface="Calibri" pitchFamily="34" charset="-120"/>
+              </a:rPr>
+              <a:t>Every decision — granted or refused — is appended to a durable record, making the boundary provable after the fact, not just at request time.</a:t>
+            </a:r>
+            <a:endParaRPr lang="en-US" sz="1050" dirty="0"/>
+          </a:p>
+        </p:txBody>
+      </p:sp>
+      <p:sp>
+        <p:nvSpPr>
+          <p:cNvPr id="26" name="Shape 23"/>
+          <p:cNvSpPr/>
+          <p:nvPr/>
+        </p:nvSpPr>
+        <p:spPr>
+          <a:xfrm>
+            <a:off x="5760720" y="5532120"/>
+            <a:ext cx="329184" cy="329184"/>
+          </a:xfrm>
+          <a:prstGeom prst="ellipse">
+            <a:avLst/>
+          </a:prstGeom>
+          <a:solidFill>
+            <a:srgbClr val="2A1B12"/>
+          </a:solidFill>
+          <a:ln w="15240">
+            <a:solidFill>
+              <a:srgbClr val="FF6C00"/>
+            </a:solidFill>
+            <a:prstDash val="solid"/>
+          </a:ln>
+        </p:spPr>
+      </p:sp>
+      <p:sp>
+        <p:nvSpPr>
+          <p:cNvPr id="27" name="Text 24"/>
+          <p:cNvSpPr/>
+          <p:nvPr/>
+        </p:nvSpPr>
+        <p:spPr>
+          <a:xfrm>
+            <a:off x="5760720" y="5532120"/>
+            <a:ext cx="329184" cy="329184"/>
+          </a:xfrm>
+          <a:prstGeom prst="rect">
+            <a:avLst/>
+          </a:prstGeom>
+          <a:noFill/>
+          <a:ln/>
+        </p:spPr>
+        <p:txBody>
+          <a:bodyPr wrap="square" lIns="0" tIns="0" rIns="0" bIns="0" rtlCol="0" anchor="ctr"/>
+          <a:lstStyle/>
+          <a:p>
+            <a:pPr algn="ctr" indent="0" marL="0">
+              <a:buNone/>
+            </a:pPr>
+            <a:r>
+              <a:rPr lang="en-US" sz="1400" b="1" dirty="0">
+                <a:solidFill>
+                  <a:srgbClr val="FF8A3D"/>
+                </a:solidFill>
+                <a:latin typeface="Cambria" pitchFamily="34" charset="0"/>
+                <a:ea typeface="Cambria" pitchFamily="34" charset="-122"/>
+                <a:cs typeface="Cambria" pitchFamily="34" charset="-120"/>
+              </a:rPr>
+              <a:t>6</a:t>
+            </a:r>
+            <a:endParaRPr lang="en-US" sz="1400" dirty="0"/>
+          </a:p>
+        </p:txBody>
+      </p:sp>
+      <p:sp>
+        <p:nvSpPr>
+          <p:cNvPr id="28" name="Text 25"/>
+          <p:cNvSpPr/>
+          <p:nvPr/>
+        </p:nvSpPr>
+        <p:spPr>
+          <a:xfrm>
+            <a:off x="6236208" y="5468112"/>
+            <a:ext cx="5285232" cy="292608"/>
+          </a:xfrm>
+          <a:prstGeom prst="rect">
+            <a:avLst/>
+          </a:prstGeom>
+          <a:noFill/>
+          <a:ln/>
+        </p:spPr>
+        <p:txBody>
+          <a:bodyPr wrap="square" lIns="0" tIns="0" rIns="0" bIns="0" rtlCol="0" anchor="ctr"/>
+          <a:lstStyle/>
+          <a:p>
+            <a:pPr indent="0" marL="0">
+              <a:buNone/>
+            </a:pPr>
+            <a:r>
+              <a:rPr lang="en-US" sz="1400" b="1" dirty="0">
+                <a:solidFill>
+                  <a:srgbClr val="E9EEF3"/>
+                </a:solidFill>
+                <a:latin typeface="Calibri" pitchFamily="34" charset="0"/>
+                <a:ea typeface="Calibri" pitchFamily="34" charset="-122"/>
+                <a:cs typeface="Calibri" pitchFamily="34" charset="-120"/>
+              </a:rPr>
               <a:t>Cognitive agent + serving</a:t>
             </a:r>
-            <a:endParaRPr lang="en-US" sz="1500" dirty="0"/>
-          </a:p>
-        </p:txBody>
-      </p:sp>
-      <p:sp>
-        <p:nvSpPr>
-          <p:cNvPr id="25" name="Text 22"/>
-          <p:cNvSpPr/>
-          <p:nvPr/>
-        </p:nvSpPr>
-        <p:spPr>
-          <a:xfrm>
-            <a:off x="6291072" y="5614416"/>
-            <a:ext cx="5230368" cy="640080"/>
+            <a:endParaRPr lang="en-US" sz="1400" dirty="0"/>
+          </a:p>
+        </p:txBody>
+      </p:sp>
+      <p:sp>
+        <p:nvSpPr>
+          <p:cNvPr id="29" name="Text 26"/>
+          <p:cNvSpPr/>
+          <p:nvPr/>
+        </p:nvSpPr>
+        <p:spPr>
+          <a:xfrm>
+            <a:off x="6236208" y="5742432"/>
+            <a:ext cx="5285232" cy="530352"/>
           </a:xfrm>
           <a:prstGeom prst="rect">
             <a:avLst/>
@@ -8558,12 +9536,12 @@
           <a:p>
             <a:pPr indent="0" marL="0">
               <a:lnSpc>
-                <a:spcPct val="105000"/>
+                <a:spcPct val="102000"/>
               </a:lnSpc>
               <a:buNone/>
             </a:pPr>
             <a:r>
-              <a:rPr lang="en-US" sz="1150" dirty="0">
+              <a:rPr lang="en-US" sz="1050" dirty="0">
                 <a:solidFill>
                   <a:srgbClr val="93A1AF"/>
                 </a:solidFill>
@@ -8573,13 +9551,13 @@
               </a:rPr>
               <a:t>Model Serving resolves plain-English intent into approved function calls, then grounds the answer in what those calls returned.</a:t>
             </a:r>
-            <a:endParaRPr lang="en-US" sz="1150" dirty="0"/>
-          </a:p>
-        </p:txBody>
-      </p:sp>
-      <p:sp>
-        <p:nvSpPr>
-          <p:cNvPr id="26" name="Text 23"/>
+            <a:endParaRPr lang="en-US" sz="1050" dirty="0"/>
+          </a:p>
+        </p:txBody>
+      </p:sp>
+      <p:sp>
+        <p:nvSpPr>
+          <p:cNvPr id="30" name="Text 27"/>
           <p:cNvSpPr/>
           <p:nvPr/>
         </p:nvSpPr>
@@ -8618,7 +9596,7 @@
       </p:sp>
       <p:sp>
         <p:nvSpPr>
-          <p:cNvPr id="27" name="Text 24"/>
+          <p:cNvPr id="31" name="Text 28"/>
           <p:cNvSpPr/>
           <p:nvPr/>
         </p:nvSpPr>
@@ -8779,7 +9757,7 @@
                 <a:ea typeface="Cambria" pitchFamily="34" charset="-122"/>
                 <a:cs typeface="Cambria" pitchFamily="34" charset="-120"/>
               </a:rPr>
-              <a:t>Five moves, two minutes</a:t>
+              <a:t>Five moves, then the receipts</a:t>
             </a:r>
             <a:endParaRPr lang="en-US" sz="3200" dirty="0"/>
           </a:p>
@@ -8818,7 +9796,7 @@
                 <a:ea typeface="Calibri" pitchFamily="34" charset="-122"/>
                 <a:cs typeface="Calibri" pitchFamily="34" charset="-120"/>
               </a:rPr>
-              <a:t>The same interface throughout. The first two show value; the last three show why you can trust it in production.</a:t>
+              <a:t>The same interface throughout. The first two show value; the next three show why you can trust it — and the Trust Center proves all five happened.</a:t>
             </a:r>
             <a:endParaRPr lang="en-US" sz="1600" dirty="0"/>
           </a:p>
@@ -8833,11 +9811,11 @@
         <p:spPr>
           <a:xfrm>
             <a:off x="640080" y="2395728"/>
-            <a:ext cx="10927080" cy="694944"/>
+            <a:ext cx="10927080" cy="640080"/>
           </a:xfrm>
           <a:prstGeom prst="roundRect">
             <a:avLst>
-              <a:gd name="adj" fmla="val 11842"/>
+              <a:gd name="adj" fmla="val 12857"/>
             </a:avLst>
           </a:prstGeom>
           <a:solidFill>
@@ -8866,8 +9844,8 @@
         </p:nvSpPr>
         <p:spPr>
           <a:xfrm>
-            <a:off x="877824" y="2569464"/>
-            <a:ext cx="384048" cy="384048"/>
+            <a:off x="877824" y="2532888"/>
+            <a:ext cx="365760" cy="365760"/>
           </a:xfrm>
           <a:prstGeom prst="ellipse">
             <a:avLst/>
@@ -8886,8 +9864,8 @@
         </p:nvSpPr>
         <p:spPr>
           <a:xfrm>
-            <a:off x="877824" y="2569464"/>
-            <a:ext cx="384048" cy="384048"/>
+            <a:off x="877824" y="2532888"/>
+            <a:ext cx="365760" cy="365760"/>
           </a:xfrm>
           <a:prstGeom prst="rect">
             <a:avLst/>
@@ -8903,7 +9881,7 @@
               <a:buNone/>
             </a:pPr>
             <a:r>
-              <a:rPr lang="en-US" sz="1700" b="1" dirty="0">
+              <a:rPr lang="en-US" sz="1600" b="1" dirty="0">
                 <a:solidFill>
                   <a:srgbClr val="0B121B"/>
                 </a:solidFill>
@@ -8913,7 +9891,7 @@
               </a:rPr>
               <a:t>1</a:t>
             </a:r>
-            <a:endParaRPr lang="en-US" sz="1700" dirty="0"/>
+            <a:endParaRPr lang="en-US" sz="1600" dirty="0"/>
           </a:p>
         </p:txBody>
       </p:sp>
@@ -8925,8 +9903,8 @@
         </p:nvSpPr>
         <p:spPr>
           <a:xfrm>
-            <a:off x="1417320" y="2395728"/>
-            <a:ext cx="2286000" cy="694944"/>
+            <a:off x="1399032" y="2395728"/>
+            <a:ext cx="2286000" cy="640080"/>
           </a:xfrm>
           <a:prstGeom prst="rect">
             <a:avLst/>
@@ -8965,7 +9943,7 @@
         <p:spPr>
           <a:xfrm>
             <a:off x="3794760" y="2395728"/>
-            <a:ext cx="3749040" cy="694944"/>
+            <a:ext cx="3749040" cy="640080"/>
           </a:xfrm>
           <a:prstGeom prst="rect">
             <a:avLst/>
@@ -9004,7 +9982,7 @@
         <p:spPr>
           <a:xfrm>
             <a:off x="7680960" y="2395728"/>
-            <a:ext cx="3657600" cy="694944"/>
+            <a:ext cx="3657600" cy="640080"/>
           </a:xfrm>
           <a:prstGeom prst="rect">
             <a:avLst/>
@@ -9045,12 +10023,12 @@
         </p:nvSpPr>
         <p:spPr>
           <a:xfrm>
-            <a:off x="640080" y="3182112"/>
-            <a:ext cx="10927080" cy="694944"/>
+            <a:off x="640080" y="3108960"/>
+            <a:ext cx="10927080" cy="640080"/>
           </a:xfrm>
           <a:prstGeom prst="roundRect">
             <a:avLst>
-              <a:gd name="adj" fmla="val 11842"/>
+              <a:gd name="adj" fmla="val 12857"/>
             </a:avLst>
           </a:prstGeom>
           <a:solidFill>
@@ -9079,8 +10057,8 @@
         </p:nvSpPr>
         <p:spPr>
           <a:xfrm>
-            <a:off x="877824" y="3355848"/>
-            <a:ext cx="384048" cy="384048"/>
+            <a:off x="877824" y="3246120"/>
+            <a:ext cx="365760" cy="365760"/>
           </a:xfrm>
           <a:prstGeom prst="ellipse">
             <a:avLst/>
@@ -9099,8 +10077,8 @@
         </p:nvSpPr>
         <p:spPr>
           <a:xfrm>
-            <a:off x="877824" y="3355848"/>
-            <a:ext cx="384048" cy="384048"/>
+            <a:off x="877824" y="3246120"/>
+            <a:ext cx="365760" cy="365760"/>
           </a:xfrm>
           <a:prstGeom prst="rect">
             <a:avLst/>
@@ -9116,7 +10094,7 @@
               <a:buNone/>
             </a:pPr>
             <a:r>
-              <a:rPr lang="en-US" sz="1700" b="1" dirty="0">
+              <a:rPr lang="en-US" sz="1600" b="1" dirty="0">
                 <a:solidFill>
                   <a:srgbClr val="0B121B"/>
                 </a:solidFill>
@@ -9126,7 +10104,7 @@
               </a:rPr>
               <a:t>2</a:t>
             </a:r>
-            <a:endParaRPr lang="en-US" sz="1700" dirty="0"/>
+            <a:endParaRPr lang="en-US" sz="1600" dirty="0"/>
           </a:p>
         </p:txBody>
       </p:sp>
@@ -9138,8 +10116,8 @@
         </p:nvSpPr>
         <p:spPr>
           <a:xfrm>
-            <a:off x="1417320" y="3182112"/>
-            <a:ext cx="2286000" cy="694944"/>
+            <a:off x="1399032" y="3108960"/>
+            <a:ext cx="2286000" cy="640080"/>
           </a:xfrm>
           <a:prstGeom prst="rect">
             <a:avLst/>
@@ -9177,8 +10155,8 @@
         </p:nvSpPr>
         <p:spPr>
           <a:xfrm>
-            <a:off x="3794760" y="3182112"/>
-            <a:ext cx="3749040" cy="694944"/>
+            <a:off x="3794760" y="3108960"/>
+            <a:ext cx="3749040" cy="640080"/>
           </a:xfrm>
           <a:prstGeom prst="rect">
             <a:avLst/>
@@ -9216,8 +10194,8 @@
         </p:nvSpPr>
         <p:spPr>
           <a:xfrm>
-            <a:off x="7680960" y="3182112"/>
-            <a:ext cx="3657600" cy="694944"/>
+            <a:off x="7680960" y="3108960"/>
+            <a:ext cx="3657600" cy="640080"/>
           </a:xfrm>
           <a:prstGeom prst="rect">
             <a:avLst/>
@@ -9258,12 +10236,12 @@
         </p:nvSpPr>
         <p:spPr>
           <a:xfrm>
-            <a:off x="640080" y="3968496"/>
-            <a:ext cx="10927080" cy="694944"/>
+            <a:off x="640080" y="3822192"/>
+            <a:ext cx="10927080" cy="640080"/>
           </a:xfrm>
           <a:prstGeom prst="roundRect">
             <a:avLst>
-              <a:gd name="adj" fmla="val 11842"/>
+              <a:gd name="adj" fmla="val 12857"/>
             </a:avLst>
           </a:prstGeom>
           <a:solidFill>
@@ -9292,8 +10270,8 @@
         </p:nvSpPr>
         <p:spPr>
           <a:xfrm>
-            <a:off x="877824" y="4142232"/>
-            <a:ext cx="384048" cy="384048"/>
+            <a:off x="877824" y="3959352"/>
+            <a:ext cx="365760" cy="365760"/>
           </a:xfrm>
           <a:prstGeom prst="ellipse">
             <a:avLst/>
@@ -9312,8 +10290,8 @@
         </p:nvSpPr>
         <p:spPr>
           <a:xfrm>
-            <a:off x="877824" y="4142232"/>
-            <a:ext cx="384048" cy="384048"/>
+            <a:off x="877824" y="3959352"/>
+            <a:ext cx="365760" cy="365760"/>
           </a:xfrm>
           <a:prstGeom prst="rect">
             <a:avLst/>
@@ -9329,7 +10307,7 @@
               <a:buNone/>
             </a:pPr>
             <a:r>
-              <a:rPr lang="en-US" sz="1700" b="1" dirty="0">
+              <a:rPr lang="en-US" sz="1600" b="1" dirty="0">
                 <a:solidFill>
                   <a:srgbClr val="0B121B"/>
                 </a:solidFill>
@@ -9339,7 +10317,7 @@
               </a:rPr>
               <a:t>3</a:t>
             </a:r>
-            <a:endParaRPr lang="en-US" sz="1700" dirty="0"/>
+            <a:endParaRPr lang="en-US" sz="1600" dirty="0"/>
           </a:p>
         </p:txBody>
       </p:sp>
@@ -9351,8 +10329,8 @@
         </p:nvSpPr>
         <p:spPr>
           <a:xfrm>
-            <a:off x="1417320" y="3968496"/>
-            <a:ext cx="2286000" cy="694944"/>
+            <a:off x="1399032" y="3822192"/>
+            <a:ext cx="2286000" cy="640080"/>
           </a:xfrm>
           <a:prstGeom prst="rect">
             <a:avLst/>
@@ -9390,8 +10368,8 @@
         </p:nvSpPr>
         <p:spPr>
           <a:xfrm>
-            <a:off x="3794760" y="3968496"/>
-            <a:ext cx="3749040" cy="694944"/>
+            <a:off x="3794760" y="3822192"/>
+            <a:ext cx="3749040" cy="640080"/>
           </a:xfrm>
           <a:prstGeom prst="rect">
             <a:avLst/>
@@ -9429,8 +10407,8 @@
         </p:nvSpPr>
         <p:spPr>
           <a:xfrm>
-            <a:off x="7680960" y="3968496"/>
-            <a:ext cx="3657600" cy="694944"/>
+            <a:off x="7680960" y="3822192"/>
+            <a:ext cx="3657600" cy="640080"/>
           </a:xfrm>
           <a:prstGeom prst="rect">
             <a:avLst/>
@@ -9471,12 +10449,12 @@
         </p:nvSpPr>
         <p:spPr>
           <a:xfrm>
-            <a:off x="640080" y="4754880"/>
-            <a:ext cx="10927080" cy="694944"/>
+            <a:off x="640080" y="4535424"/>
+            <a:ext cx="10927080" cy="640080"/>
           </a:xfrm>
           <a:prstGeom prst="roundRect">
             <a:avLst>
-              <a:gd name="adj" fmla="val 11842"/>
+              <a:gd name="adj" fmla="val 12857"/>
             </a:avLst>
           </a:prstGeom>
           <a:solidFill>
@@ -9505,8 +10483,8 @@
         </p:nvSpPr>
         <p:spPr>
           <a:xfrm>
-            <a:off x="877824" y="4928616"/>
-            <a:ext cx="384048" cy="384048"/>
+            <a:off x="877824" y="4672584"/>
+            <a:ext cx="365760" cy="365760"/>
           </a:xfrm>
           <a:prstGeom prst="ellipse">
             <a:avLst/>
@@ -9525,8 +10503,8 @@
         </p:nvSpPr>
         <p:spPr>
           <a:xfrm>
-            <a:off x="877824" y="4928616"/>
-            <a:ext cx="384048" cy="384048"/>
+            <a:off x="877824" y="4672584"/>
+            <a:ext cx="365760" cy="365760"/>
           </a:xfrm>
           <a:prstGeom prst="rect">
             <a:avLst/>
@@ -9542,7 +10520,7 @@
               <a:buNone/>
             </a:pPr>
             <a:r>
-              <a:rPr lang="en-US" sz="1700" b="1" dirty="0">
+              <a:rPr lang="en-US" sz="1600" b="1" dirty="0">
                 <a:solidFill>
                   <a:srgbClr val="0B121B"/>
                 </a:solidFill>
@@ -9552,7 +10530,7 @@
               </a:rPr>
               <a:t>4</a:t>
             </a:r>
-            <a:endParaRPr lang="en-US" sz="1700" dirty="0"/>
+            <a:endParaRPr lang="en-US" sz="1600" dirty="0"/>
           </a:p>
         </p:txBody>
       </p:sp>
@@ -9564,8 +10542,8 @@
         </p:nvSpPr>
         <p:spPr>
           <a:xfrm>
-            <a:off x="1417320" y="4754880"/>
-            <a:ext cx="2286000" cy="694944"/>
+            <a:off x="1399032" y="4535424"/>
+            <a:ext cx="2286000" cy="640080"/>
           </a:xfrm>
           <a:prstGeom prst="rect">
             <a:avLst/>
@@ -9603,8 +10581,8 @@
         </p:nvSpPr>
         <p:spPr>
           <a:xfrm>
-            <a:off x="3794760" y="4754880"/>
-            <a:ext cx="3749040" cy="694944"/>
+            <a:off x="3794760" y="4535424"/>
+            <a:ext cx="3749040" cy="640080"/>
           </a:xfrm>
           <a:prstGeom prst="rect">
             <a:avLst/>
@@ -9642,8 +10620,8 @@
         </p:nvSpPr>
         <p:spPr>
           <a:xfrm>
-            <a:off x="7680960" y="4754880"/>
-            <a:ext cx="3657600" cy="694944"/>
+            <a:off x="7680960" y="4535424"/>
+            <a:ext cx="3657600" cy="640080"/>
           </a:xfrm>
           <a:prstGeom prst="rect">
             <a:avLst/>
@@ -9684,12 +10662,12 @@
         </p:nvSpPr>
         <p:spPr>
           <a:xfrm>
-            <a:off x="640080" y="5541264"/>
-            <a:ext cx="10927080" cy="694944"/>
+            <a:off x="640080" y="5248656"/>
+            <a:ext cx="10927080" cy="640080"/>
           </a:xfrm>
           <a:prstGeom prst="roundRect">
             <a:avLst>
-              <a:gd name="adj" fmla="val 11842"/>
+              <a:gd name="adj" fmla="val 12857"/>
             </a:avLst>
           </a:prstGeom>
           <a:solidFill>
@@ -9718,8 +10696,8 @@
         </p:nvSpPr>
         <p:spPr>
           <a:xfrm>
-            <a:off x="877824" y="5715000"/>
-            <a:ext cx="384048" cy="384048"/>
+            <a:off x="877824" y="5385816"/>
+            <a:ext cx="365760" cy="365760"/>
           </a:xfrm>
           <a:prstGeom prst="ellipse">
             <a:avLst/>
@@ -9738,8 +10716,8 @@
         </p:nvSpPr>
         <p:spPr>
           <a:xfrm>
-            <a:off x="877824" y="5715000"/>
-            <a:ext cx="384048" cy="384048"/>
+            <a:off x="877824" y="5385816"/>
+            <a:ext cx="365760" cy="365760"/>
           </a:xfrm>
           <a:prstGeom prst="rect">
             <a:avLst/>
@@ -9755,7 +10733,7 @@
               <a:buNone/>
             </a:pPr>
             <a:r>
-              <a:rPr lang="en-US" sz="1700" b="1" dirty="0">
+              <a:rPr lang="en-US" sz="1600" b="1" dirty="0">
                 <a:solidFill>
                   <a:srgbClr val="0B121B"/>
                 </a:solidFill>
@@ -9765,7 +10743,7 @@
               </a:rPr>
               <a:t>5</a:t>
             </a:r>
-            <a:endParaRPr lang="en-US" sz="1700" dirty="0"/>
+            <a:endParaRPr lang="en-US" sz="1600" dirty="0"/>
           </a:p>
         </p:txBody>
       </p:sp>
@@ -9777,8 +10755,8 @@
         </p:nvSpPr>
         <p:spPr>
           <a:xfrm>
-            <a:off x="1417320" y="5541264"/>
-            <a:ext cx="2286000" cy="694944"/>
+            <a:off x="1399032" y="5248656"/>
+            <a:ext cx="2286000" cy="640080"/>
           </a:xfrm>
           <a:prstGeom prst="rect">
             <a:avLst/>
@@ -9816,8 +10794,8 @@
         </p:nvSpPr>
         <p:spPr>
           <a:xfrm>
-            <a:off x="3794760" y="5541264"/>
-            <a:ext cx="3749040" cy="694944"/>
+            <a:off x="3794760" y="5248656"/>
+            <a:ext cx="3749040" cy="640080"/>
           </a:xfrm>
           <a:prstGeom prst="rect">
             <a:avLst/>
@@ -9855,8 +10833,8 @@
         </p:nvSpPr>
         <p:spPr>
           <a:xfrm>
-            <a:off x="7680960" y="5541264"/>
-            <a:ext cx="3657600" cy="694944"/>
+            <a:off x="7680960" y="5248656"/>
+            <a:ext cx="3657600" cy="640080"/>
           </a:xfrm>
           <a:prstGeom prst="rect">
             <a:avLst/>
@@ -9897,6 +10875,45 @@
         </p:nvSpPr>
         <p:spPr>
           <a:xfrm>
+            <a:off x="640080" y="6053328"/>
+            <a:ext cx="10881360" cy="274320"/>
+          </a:xfrm>
+          <a:prstGeom prst="rect">
+            <a:avLst/>
+          </a:prstGeom>
+          <a:noFill/>
+          <a:ln/>
+        </p:spPr>
+        <p:txBody>
+          <a:bodyPr wrap="square" lIns="0" tIns="0" rIns="0" bIns="0" rtlCol="0" anchor="ctr"/>
+          <a:lstStyle/>
+          <a:p>
+            <a:pPr indent="0" marL="0">
+              <a:buNone/>
+            </a:pPr>
+            <a:r>
+              <a:rPr lang="en-US" sz="1350" i="1" dirty="0">
+                <a:solidFill>
+                  <a:srgbClr val="FF8A3D"/>
+                </a:solidFill>
+                <a:latin typeface="Calibri" pitchFamily="34" charset="0"/>
+                <a:ea typeface="Calibri" pitchFamily="34" charset="-122"/>
+                <a:cs typeface="Calibri" pitchFamily="34" charset="-120"/>
+              </a:rPr>
+              <a:t>Then open the Trust Center tab — every one of these is already on the record.</a:t>
+            </a:r>
+            <a:endParaRPr lang="en-US" sz="1350" dirty="0"/>
+          </a:p>
+        </p:txBody>
+      </p:sp>
+      <p:sp>
+        <p:nvSpPr>
+          <p:cNvPr id="37" name="Text 35"/>
+          <p:cNvSpPr/>
+          <p:nvPr/>
+        </p:nvSpPr>
+        <p:spPr>
+          <a:xfrm>
             <a:off x="11277295" y="6400800"/>
             <a:ext cx="548640" cy="274320"/>
           </a:xfrm>
@@ -9930,7 +10947,7 @@
       </p:sp>
       <p:sp>
         <p:nvSpPr>
-          <p:cNvPr id="37" name="Text 35"/>
+          <p:cNvPr id="38" name="Text 36"/>
           <p:cNvSpPr/>
           <p:nvPr/>
         </p:nvSpPr>
@@ -10532,7 +11549,7 @@
                 <a:ea typeface="Calibri" pitchFamily="34" charset="-122"/>
                 <a:cs typeface="Calibri" pitchFamily="34" charset="-120"/>
               </a:rPr>
-              <a:t>Ask about a different customer and the numbers change, because they are read from the gold layer — the dashboard and the agent cannot disagree.</a:t>
+              <a:t>Seeding is deterministic — clone the repo, run one command, and reproduce these exact figures on your own machine.</a:t>
             </a:r>
             <a:endParaRPr lang="en-US" sz="1450" dirty="0"/>
           </a:p>
@@ -12340,7 +13357,7 @@
     <p:bg>
       <p:bgPr>
         <a:solidFill>
-          <a:srgbClr val="0E1621"/>
+          <a:srgbClr val="0B121B"/>
         </a:solidFill>
       </p:bgPr>
     </p:bg>
@@ -12411,7 +13428,7 @@
                 <a:ea typeface="Calibri" pitchFamily="34" charset="-122"/>
                 <a:cs typeface="Calibri" pitchFamily="34" charset="-120"/>
               </a:rPr>
-              <a:t>UNDER THE HOOD</a:t>
+              <a:t>THE RECEIPTS</a:t>
             </a:r>
             <a:endParaRPr lang="en-US" sz="1200" dirty="0"/>
           </a:p>
@@ -12450,45 +13467,581 @@
                 <a:ea typeface="Cambria" pitchFamily="34" charset="-122"/>
                 <a:cs typeface="Cambria" pitchFamily="34" charset="-120"/>
               </a:rPr>
-              <a:t>Why the answers hold up</a:t>
+              <a:t>Proving it after the fact</a:t>
             </a:r>
             <a:endParaRPr lang="en-US" sz="3200" dirty="0"/>
           </a:p>
         </p:txBody>
       </p:sp>
-      <p:pic>
-        <p:nvPicPr>
-          <p:cNvPr id="5" name="Image 0" descr="/private/tmp/claude-501/-Users-atharvvani-Downloads-DataBricks/437ba0b1-41b9-48e1-95cf-333721d11260/scratchpad/deck_assets/latency_dist.png">    </p:cNvPr>
-          <p:cNvPicPr>
-            <a:picLocks noChangeAspect="1"/>
-          </p:cNvPicPr>
-          <p:nvPr/>
-        </p:nvPicPr>
-        <p:blipFill>
-          <a:blip r:embed="rId1"/>
-          <a:stretch>
-            <a:fillRect/>
-          </a:stretch>
-        </p:blipFill>
-        <p:spPr>
-          <a:xfrm>
-            <a:off x="640080" y="1828800"/>
-            <a:ext cx="6766560" cy="2926080"/>
-          </a:xfrm>
-          <a:prstGeom prst="rect">
-            <a:avLst/>
-          </a:prstGeom>
-        </p:spPr>
-      </p:pic>
-      <p:sp>
-        <p:nvSpPr>
-          <p:cNvPr id="6" name="Shape 3"/>
-          <p:cNvSpPr/>
-          <p:nvPr/>
-        </p:nvSpPr>
-        <p:spPr>
-          <a:xfrm>
-            <a:off x="7772400" y="1764792"/>
+      <p:sp>
+        <p:nvSpPr>
+          <p:cNvPr id="5" name="Text 3"/>
+          <p:cNvSpPr/>
+          <p:nvPr/>
+        </p:nvSpPr>
+        <p:spPr>
+          <a:xfrm>
+            <a:off x="640080" y="1783080"/>
+            <a:ext cx="10789920" cy="457200"/>
+          </a:xfrm>
+          <a:prstGeom prst="rect">
+            <a:avLst/>
+          </a:prstGeom>
+          <a:noFill/>
+          <a:ln/>
+        </p:spPr>
+        <p:txBody>
+          <a:bodyPr wrap="square" lIns="0" tIns="0" rIns="0" bIns="0" rtlCol="0" anchor="ctr"/>
+          <a:lstStyle/>
+          <a:p>
+            <a:pPr indent="0" marL="0">
+              <a:buNone/>
+            </a:pPr>
+            <a:r>
+              <a:rPr lang="en-US" sz="1600" dirty="0">
+                <a:solidFill>
+                  <a:srgbClr val="93A1AF"/>
+                </a:solidFill>
+                <a:latin typeface="Calibri" pitchFamily="34" charset="0"/>
+                <a:ea typeface="Calibri" pitchFamily="34" charset="-122"/>
+                <a:cs typeface="Calibri" pitchFamily="34" charset="-120"/>
+              </a:rPr>
+              <a:t>A control you cannot evidence is a control you cannot pass an audit with. Every decision — granted or refused — is appended to a durable trail.</a:t>
+            </a:r>
+            <a:endParaRPr lang="en-US" sz="1600" dirty="0"/>
+          </a:p>
+        </p:txBody>
+      </p:sp>
+      <p:sp>
+        <p:nvSpPr>
+          <p:cNvPr id="6" name="Shape 4"/>
+          <p:cNvSpPr/>
+          <p:nvPr/>
+        </p:nvSpPr>
+        <p:spPr>
+          <a:xfrm>
+            <a:off x="640080" y="2331720"/>
+            <a:ext cx="2615184" cy="960120"/>
+          </a:xfrm>
+          <a:prstGeom prst="roundRect">
+            <a:avLst>
+              <a:gd name="adj" fmla="val 8571"/>
+            </a:avLst>
+          </a:prstGeom>
+          <a:solidFill>
+            <a:srgbClr val="18232F"/>
+          </a:solidFill>
+          <a:ln w="12700">
+            <a:solidFill>
+              <a:srgbClr val="2A3745"/>
+            </a:solidFill>
+            <a:prstDash val="solid"/>
+          </a:ln>
+          <a:effectLst>
+            <a:outerShdw sx="100000" sy="100000" kx="0" ky="0" algn="bl" rotWithShape="0" blurRad="114300" dist="38100" dir="5400000">
+              <a:srgbClr val="000000">
+                <a:alpha val="28000"/>
+              </a:srgbClr>
+            </a:outerShdw>
+          </a:effectLst>
+        </p:spPr>
+      </p:sp>
+      <p:sp>
+        <p:nvSpPr>
+          <p:cNvPr id="7" name="Text 5"/>
+          <p:cNvSpPr/>
+          <p:nvPr/>
+        </p:nvSpPr>
+        <p:spPr>
+          <a:xfrm>
+            <a:off x="868680" y="2395728"/>
+            <a:ext cx="2157984" cy="502920"/>
+          </a:xfrm>
+          <a:prstGeom prst="rect">
+            <a:avLst/>
+          </a:prstGeom>
+          <a:noFill/>
+          <a:ln/>
+        </p:spPr>
+        <p:txBody>
+          <a:bodyPr wrap="square" lIns="0" tIns="0" rIns="0" bIns="0" rtlCol="0" anchor="ctr"/>
+          <a:lstStyle/>
+          <a:p>
+            <a:pPr indent="0" marL="0">
+              <a:buNone/>
+            </a:pPr>
+            <a:r>
+              <a:rPr lang="en-US" sz="2500" b="1" dirty="0">
+                <a:solidFill>
+                  <a:srgbClr val="FF8A3D"/>
+                </a:solidFill>
+                <a:latin typeface="Cambria" pitchFamily="34" charset="0"/>
+                <a:ea typeface="Cambria" pitchFamily="34" charset="-122"/>
+                <a:cs typeface="Cambria" pitchFamily="34" charset="-120"/>
+              </a:rPr>
+              <a:t>6</a:t>
+            </a:r>
+            <a:endParaRPr lang="en-US" sz="2500" dirty="0"/>
+          </a:p>
+        </p:txBody>
+      </p:sp>
+      <p:sp>
+        <p:nvSpPr>
+          <p:cNvPr id="8" name="Text 6"/>
+          <p:cNvSpPr/>
+          <p:nvPr/>
+        </p:nvSpPr>
+        <p:spPr>
+          <a:xfrm>
+            <a:off x="868680" y="2889504"/>
+            <a:ext cx="2157984" cy="274320"/>
+          </a:xfrm>
+          <a:prstGeom prst="rect">
+            <a:avLst/>
+          </a:prstGeom>
+          <a:noFill/>
+          <a:ln/>
+        </p:spPr>
+        <p:txBody>
+          <a:bodyPr wrap="square" lIns="0" tIns="0" rIns="0" bIns="0" rtlCol="0" anchor="ctr"/>
+          <a:lstStyle/>
+          <a:p>
+            <a:pPr indent="0" marL="0">
+              <a:buNone/>
+            </a:pPr>
+            <a:r>
+              <a:rPr lang="en-US" sz="1050" b="1" spc="120" kern="0" dirty="0">
+                <a:solidFill>
+                  <a:srgbClr val="93A1AF"/>
+                </a:solidFill>
+                <a:latin typeface="Calibri" pitchFamily="34" charset="0"/>
+                <a:ea typeface="Calibri" pitchFamily="34" charset="-122"/>
+                <a:cs typeface="Calibri" pitchFamily="34" charset="-120"/>
+              </a:rPr>
+              <a:t>GOVERNED ACTIONS</a:t>
+            </a:r>
+            <a:endParaRPr lang="en-US" sz="1050" dirty="0"/>
+          </a:p>
+        </p:txBody>
+      </p:sp>
+      <p:sp>
+        <p:nvSpPr>
+          <p:cNvPr id="9" name="Shape 7"/>
+          <p:cNvSpPr/>
+          <p:nvPr/>
+        </p:nvSpPr>
+        <p:spPr>
+          <a:xfrm>
+            <a:off x="3429000" y="2331720"/>
+            <a:ext cx="2615184" cy="960120"/>
+          </a:xfrm>
+          <a:prstGeom prst="roundRect">
+            <a:avLst>
+              <a:gd name="adj" fmla="val 8571"/>
+            </a:avLst>
+          </a:prstGeom>
+          <a:solidFill>
+            <a:srgbClr val="18232F"/>
+          </a:solidFill>
+          <a:ln w="12700">
+            <a:solidFill>
+              <a:srgbClr val="2A3745"/>
+            </a:solidFill>
+            <a:prstDash val="solid"/>
+          </a:ln>
+          <a:effectLst>
+            <a:outerShdw sx="100000" sy="100000" kx="0" ky="0" algn="bl" rotWithShape="0" blurRad="114300" dist="38100" dir="5400000">
+              <a:srgbClr val="000000">
+                <a:alpha val="28000"/>
+              </a:srgbClr>
+            </a:outerShdw>
+          </a:effectLst>
+        </p:spPr>
+      </p:sp>
+      <p:sp>
+        <p:nvSpPr>
+          <p:cNvPr id="10" name="Text 8"/>
+          <p:cNvSpPr/>
+          <p:nvPr/>
+        </p:nvSpPr>
+        <p:spPr>
+          <a:xfrm>
+            <a:off x="3657600" y="2395728"/>
+            <a:ext cx="2157984" cy="502920"/>
+          </a:xfrm>
+          <a:prstGeom prst="rect">
+            <a:avLst/>
+          </a:prstGeom>
+          <a:noFill/>
+          <a:ln/>
+        </p:spPr>
+        <p:txBody>
+          <a:bodyPr wrap="square" lIns="0" tIns="0" rIns="0" bIns="0" rtlCol="0" anchor="ctr"/>
+          <a:lstStyle/>
+          <a:p>
+            <a:pPr indent="0" marL="0">
+              <a:buNone/>
+            </a:pPr>
+            <a:r>
+              <a:rPr lang="en-US" sz="2500" b="1" dirty="0">
+                <a:solidFill>
+                  <a:srgbClr val="FF8A3D"/>
+                </a:solidFill>
+                <a:latin typeface="Cambria" pitchFamily="34" charset="0"/>
+                <a:ea typeface="Cambria" pitchFamily="34" charset="-122"/>
+                <a:cs typeface="Cambria" pitchFamily="34" charset="-120"/>
+              </a:rPr>
+              <a:t>5</a:t>
+            </a:r>
+            <a:endParaRPr lang="en-US" sz="2500" dirty="0"/>
+          </a:p>
+        </p:txBody>
+      </p:sp>
+      <p:sp>
+        <p:nvSpPr>
+          <p:cNvPr id="11" name="Text 9"/>
+          <p:cNvSpPr/>
+          <p:nvPr/>
+        </p:nvSpPr>
+        <p:spPr>
+          <a:xfrm>
+            <a:off x="3657600" y="2889504"/>
+            <a:ext cx="2157984" cy="274320"/>
+          </a:xfrm>
+          <a:prstGeom prst="rect">
+            <a:avLst/>
+          </a:prstGeom>
+          <a:noFill/>
+          <a:ln/>
+        </p:spPr>
+        <p:txBody>
+          <a:bodyPr wrap="square" lIns="0" tIns="0" rIns="0" bIns="0" rtlCol="0" anchor="ctr"/>
+          <a:lstStyle/>
+          <a:p>
+            <a:pPr indent="0" marL="0">
+              <a:buNone/>
+            </a:pPr>
+            <a:r>
+              <a:rPr lang="en-US" sz="1050" b="1" spc="120" kern="0" dirty="0">
+                <a:solidFill>
+                  <a:srgbClr val="93A1AF"/>
+                </a:solidFill>
+                <a:latin typeface="Calibri" pitchFamily="34" charset="0"/>
+                <a:ea typeface="Calibri" pitchFamily="34" charset="-122"/>
+                <a:cs typeface="Calibri" pitchFamily="34" charset="-120"/>
+              </a:rPr>
+              <a:t>GRANTED</a:t>
+            </a:r>
+            <a:endParaRPr lang="en-US" sz="1050" dirty="0"/>
+          </a:p>
+        </p:txBody>
+      </p:sp>
+      <p:sp>
+        <p:nvSpPr>
+          <p:cNvPr id="12" name="Shape 10"/>
+          <p:cNvSpPr/>
+          <p:nvPr/>
+        </p:nvSpPr>
+        <p:spPr>
+          <a:xfrm>
+            <a:off x="6217920" y="2331720"/>
+            <a:ext cx="2615184" cy="960120"/>
+          </a:xfrm>
+          <a:prstGeom prst="roundRect">
+            <a:avLst>
+              <a:gd name="adj" fmla="val 8571"/>
+            </a:avLst>
+          </a:prstGeom>
+          <a:solidFill>
+            <a:srgbClr val="1F2C3A"/>
+          </a:solidFill>
+          <a:ln w="12700">
+            <a:solidFill>
+              <a:srgbClr val="2A3745"/>
+            </a:solidFill>
+            <a:prstDash val="solid"/>
+          </a:ln>
+          <a:effectLst>
+            <a:outerShdw sx="100000" sy="100000" kx="0" ky="0" algn="bl" rotWithShape="0" blurRad="114300" dist="38100" dir="5400000">
+              <a:srgbClr val="000000">
+                <a:alpha val="28000"/>
+              </a:srgbClr>
+            </a:outerShdw>
+          </a:effectLst>
+        </p:spPr>
+      </p:sp>
+      <p:sp>
+        <p:nvSpPr>
+          <p:cNvPr id="13" name="Text 11"/>
+          <p:cNvSpPr/>
+          <p:nvPr/>
+        </p:nvSpPr>
+        <p:spPr>
+          <a:xfrm>
+            <a:off x="6446520" y="2395728"/>
+            <a:ext cx="2157984" cy="502920"/>
+          </a:xfrm>
+          <a:prstGeom prst="rect">
+            <a:avLst/>
+          </a:prstGeom>
+          <a:noFill/>
+          <a:ln/>
+        </p:spPr>
+        <p:txBody>
+          <a:bodyPr wrap="square" lIns="0" tIns="0" rIns="0" bIns="0" rtlCol="0" anchor="ctr"/>
+          <a:lstStyle/>
+          <a:p>
+            <a:pPr indent="0" marL="0">
+              <a:buNone/>
+            </a:pPr>
+            <a:r>
+              <a:rPr lang="en-US" sz="2500" b="1" dirty="0">
+                <a:solidFill>
+                  <a:srgbClr val="F85149"/>
+                </a:solidFill>
+                <a:latin typeface="Cambria" pitchFamily="34" charset="0"/>
+                <a:ea typeface="Cambria" pitchFamily="34" charset="-122"/>
+                <a:cs typeface="Cambria" pitchFamily="34" charset="-120"/>
+              </a:rPr>
+              <a:t>1</a:t>
+            </a:r>
+            <a:endParaRPr lang="en-US" sz="2500" dirty="0"/>
+          </a:p>
+        </p:txBody>
+      </p:sp>
+      <p:sp>
+        <p:nvSpPr>
+          <p:cNvPr id="14" name="Text 12"/>
+          <p:cNvSpPr/>
+          <p:nvPr/>
+        </p:nvSpPr>
+        <p:spPr>
+          <a:xfrm>
+            <a:off x="6446520" y="2889504"/>
+            <a:ext cx="2157984" cy="274320"/>
+          </a:xfrm>
+          <a:prstGeom prst="rect">
+            <a:avLst/>
+          </a:prstGeom>
+          <a:noFill/>
+          <a:ln/>
+        </p:spPr>
+        <p:txBody>
+          <a:bodyPr wrap="square" lIns="0" tIns="0" rIns="0" bIns="0" rtlCol="0" anchor="ctr"/>
+          <a:lstStyle/>
+          <a:p>
+            <a:pPr indent="0" marL="0">
+              <a:buNone/>
+            </a:pPr>
+            <a:r>
+              <a:rPr lang="en-US" sz="1050" b="1" spc="120" kern="0" dirty="0">
+                <a:solidFill>
+                  <a:srgbClr val="93A1AF"/>
+                </a:solidFill>
+                <a:latin typeface="Calibri" pitchFamily="34" charset="0"/>
+                <a:ea typeface="Calibri" pitchFamily="34" charset="-122"/>
+                <a:cs typeface="Calibri" pitchFamily="34" charset="-120"/>
+              </a:rPr>
+              <a:t>DENIED</a:t>
+            </a:r>
+            <a:endParaRPr lang="en-US" sz="1050" dirty="0"/>
+          </a:p>
+        </p:txBody>
+      </p:sp>
+      <p:sp>
+        <p:nvSpPr>
+          <p:cNvPr id="15" name="Shape 13"/>
+          <p:cNvSpPr/>
+          <p:nvPr/>
+        </p:nvSpPr>
+        <p:spPr>
+          <a:xfrm>
+            <a:off x="9006840" y="2331720"/>
+            <a:ext cx="2615184" cy="960120"/>
+          </a:xfrm>
+          <a:prstGeom prst="roundRect">
+            <a:avLst>
+              <a:gd name="adj" fmla="val 8571"/>
+            </a:avLst>
+          </a:prstGeom>
+          <a:solidFill>
+            <a:srgbClr val="18232F"/>
+          </a:solidFill>
+          <a:ln w="12700">
+            <a:solidFill>
+              <a:srgbClr val="2A3745"/>
+            </a:solidFill>
+            <a:prstDash val="solid"/>
+          </a:ln>
+          <a:effectLst>
+            <a:outerShdw sx="100000" sy="100000" kx="0" ky="0" algn="bl" rotWithShape="0" blurRad="114300" dist="38100" dir="5400000">
+              <a:srgbClr val="000000">
+                <a:alpha val="28000"/>
+              </a:srgbClr>
+            </a:outerShdw>
+          </a:effectLst>
+        </p:spPr>
+      </p:sp>
+      <p:sp>
+        <p:nvSpPr>
+          <p:cNvPr id="16" name="Text 14"/>
+          <p:cNvSpPr/>
+          <p:nvPr/>
+        </p:nvSpPr>
+        <p:spPr>
+          <a:xfrm>
+            <a:off x="9235440" y="2395728"/>
+            <a:ext cx="2157984" cy="502920"/>
+          </a:xfrm>
+          <a:prstGeom prst="rect">
+            <a:avLst/>
+          </a:prstGeom>
+          <a:noFill/>
+          <a:ln/>
+        </p:spPr>
+        <p:txBody>
+          <a:bodyPr wrap="square" lIns="0" tIns="0" rIns="0" bIns="0" rtlCol="0" anchor="ctr"/>
+          <a:lstStyle/>
+          <a:p>
+            <a:pPr indent="0" marL="0">
+              <a:buNone/>
+            </a:pPr>
+            <a:r>
+              <a:rPr lang="en-US" sz="2500" b="1" dirty="0">
+                <a:solidFill>
+                  <a:srgbClr val="FF8A3D"/>
+                </a:solidFill>
+                <a:latin typeface="Cambria" pitchFamily="34" charset="0"/>
+                <a:ea typeface="Cambria" pitchFamily="34" charset="-122"/>
+                <a:cs typeface="Cambria" pitchFamily="34" charset="-120"/>
+              </a:rPr>
+              <a:t>16.7%</a:t>
+            </a:r>
+            <a:endParaRPr lang="en-US" sz="2500" dirty="0"/>
+          </a:p>
+        </p:txBody>
+      </p:sp>
+      <p:sp>
+        <p:nvSpPr>
+          <p:cNvPr id="17" name="Text 15"/>
+          <p:cNvSpPr/>
+          <p:nvPr/>
+        </p:nvSpPr>
+        <p:spPr>
+          <a:xfrm>
+            <a:off x="9235440" y="2889504"/>
+            <a:ext cx="2157984" cy="274320"/>
+          </a:xfrm>
+          <a:prstGeom prst="rect">
+            <a:avLst/>
+          </a:prstGeom>
+          <a:noFill/>
+          <a:ln/>
+        </p:spPr>
+        <p:txBody>
+          <a:bodyPr wrap="square" lIns="0" tIns="0" rIns="0" bIns="0" rtlCol="0" anchor="ctr"/>
+          <a:lstStyle/>
+          <a:p>
+            <a:pPr indent="0" marL="0">
+              <a:buNone/>
+            </a:pPr>
+            <a:r>
+              <a:rPr lang="en-US" sz="1050" b="1" spc="120" kern="0" dirty="0">
+                <a:solidFill>
+                  <a:srgbClr val="93A1AF"/>
+                </a:solidFill>
+                <a:latin typeface="Calibri" pitchFamily="34" charset="0"/>
+                <a:ea typeface="Calibri" pitchFamily="34" charset="-122"/>
+                <a:cs typeface="Calibri" pitchFamily="34" charset="-120"/>
+              </a:rPr>
+              <a:t>DENIAL RATE</a:t>
+            </a:r>
+            <a:endParaRPr lang="en-US" sz="1050" dirty="0"/>
+          </a:p>
+        </p:txBody>
+      </p:sp>
+      <p:sp>
+        <p:nvSpPr>
+          <p:cNvPr id="18" name="Text 16"/>
+          <p:cNvSpPr/>
+          <p:nvPr/>
+        </p:nvSpPr>
+        <p:spPr>
+          <a:xfrm>
+            <a:off x="640080" y="3364992"/>
+            <a:ext cx="10881360" cy="256032"/>
+          </a:xfrm>
+          <a:prstGeom prst="rect">
+            <a:avLst/>
+          </a:prstGeom>
+          <a:noFill/>
+          <a:ln/>
+        </p:spPr>
+        <p:txBody>
+          <a:bodyPr wrap="square" lIns="0" tIns="0" rIns="0" bIns="0" rtlCol="0" anchor="ctr"/>
+          <a:lstStyle/>
+          <a:p>
+            <a:pPr indent="0" marL="0">
+              <a:buNone/>
+            </a:pPr>
+            <a:r>
+              <a:rPr lang="en-US" sz="1150" i="1" dirty="0">
+                <a:solidFill>
+                  <a:srgbClr val="6C7C8A"/>
+                </a:solidFill>
+                <a:latin typeface="Calibri" pitchFamily="34" charset="0"/>
+                <a:ea typeface="Calibri" pitchFamily="34" charset="-122"/>
+                <a:cs typeface="Calibri" pitchFamily="34" charset="-120"/>
+              </a:rPr>
+              <a:t>the five demo moves, already on the record</a:t>
+            </a:r>
+            <a:endParaRPr lang="en-US" sz="1150" dirty="0"/>
+          </a:p>
+        </p:txBody>
+      </p:sp>
+      <p:sp>
+        <p:nvSpPr>
+          <p:cNvPr id="19" name="Shape 17"/>
+          <p:cNvSpPr/>
+          <p:nvPr/>
+        </p:nvSpPr>
+        <p:spPr>
+          <a:xfrm>
+            <a:off x="640080" y="3675888"/>
+            <a:ext cx="5257800" cy="1051560"/>
+          </a:xfrm>
+          <a:prstGeom prst="roundRect">
+            <a:avLst>
+              <a:gd name="adj" fmla="val 7826"/>
+            </a:avLst>
+          </a:prstGeom>
+          <a:solidFill>
+            <a:srgbClr val="18232F"/>
+          </a:solidFill>
+          <a:ln w="12700">
+            <a:solidFill>
+              <a:srgbClr val="2A3745"/>
+            </a:solidFill>
+            <a:prstDash val="solid"/>
+          </a:ln>
+          <a:effectLst>
+            <a:outerShdw sx="100000" sy="100000" kx="0" ky="0" algn="bl" rotWithShape="0" blurRad="114300" dist="38100" dir="5400000">
+              <a:srgbClr val="000000">
+                <a:alpha val="28000"/>
+              </a:srgbClr>
+            </a:outerShdw>
+          </a:effectLst>
+        </p:spPr>
+      </p:sp>
+      <p:sp>
+        <p:nvSpPr>
+          <p:cNvPr id="20" name="Shape 18"/>
+          <p:cNvSpPr/>
+          <p:nvPr/>
+        </p:nvSpPr>
+        <p:spPr>
+          <a:xfrm>
+            <a:off x="914400" y="3895344"/>
             <a:ext cx="146304" cy="146304"/>
           </a:xfrm>
           <a:prstGeom prst="ellipse">
@@ -12502,30 +14055,30 @@
       </p:sp>
       <p:sp>
         <p:nvSpPr>
-          <p:cNvPr id="7" name="Text 4"/>
-          <p:cNvSpPr/>
-          <p:nvPr/>
-        </p:nvSpPr>
-        <p:spPr>
-          <a:xfrm>
-            <a:off x="8046720" y="1645920"/>
-            <a:ext cx="3474720" cy="365760"/>
-          </a:xfrm>
-          <a:prstGeom prst="rect">
-            <a:avLst/>
-          </a:prstGeom>
-          <a:noFill/>
-          <a:ln/>
-        </p:spPr>
-        <p:txBody>
-          <a:bodyPr wrap="square" lIns="0" tIns="0" rIns="0" bIns="0" rtlCol="0" anchor="ctr"/>
-          <a:lstStyle/>
-          <a:p>
-            <a:pPr indent="0" marL="0">
-              <a:buNone/>
-            </a:pPr>
-            <a:r>
-              <a:rPr lang="en-US" sz="1550" b="1" dirty="0">
+          <p:cNvPr id="21" name="Text 19"/>
+          <p:cNvSpPr/>
+          <p:nvPr/>
+        </p:nvSpPr>
+        <p:spPr>
+          <a:xfrm>
+            <a:off x="1188720" y="3785616"/>
+            <a:ext cx="4480560" cy="292608"/>
+          </a:xfrm>
+          <a:prstGeom prst="rect">
+            <a:avLst/>
+          </a:prstGeom>
+          <a:noFill/>
+          <a:ln/>
+        </p:spPr>
+        <p:txBody>
+          <a:bodyPr wrap="square" lIns="0" tIns="0" rIns="0" bIns="0" rtlCol="0" anchor="ctr"/>
+          <a:lstStyle/>
+          <a:p>
+            <a:pPr indent="0" marL="0">
+              <a:buNone/>
+            </a:pPr>
+            <a:r>
+              <a:rPr lang="en-US" sz="1400" b="1" dirty="0">
                 <a:solidFill>
                   <a:srgbClr val="E9EEF3"/>
                 </a:solidFill>
@@ -12533,22 +14086,22 @@
                 <a:ea typeface="Calibri" pitchFamily="34" charset="-122"/>
                 <a:cs typeface="Calibri" pitchFamily="34" charset="-120"/>
               </a:rPr>
-              <a:t>Statistical, not hard-coded</a:t>
-            </a:r>
-            <a:endParaRPr lang="en-US" sz="1550" dirty="0"/>
-          </a:p>
-        </p:txBody>
-      </p:sp>
-      <p:sp>
-        <p:nvSpPr>
-          <p:cNvPr id="8" name="Text 5"/>
-          <p:cNvSpPr/>
-          <p:nvPr/>
-        </p:nvSpPr>
-        <p:spPr>
-          <a:xfrm>
-            <a:off x="8046720" y="2029968"/>
-            <a:ext cx="3474720" cy="822960"/>
+              <a:t>Append-only</a:t>
+            </a:r>
+            <a:endParaRPr lang="en-US" sz="1400" dirty="0"/>
+          </a:p>
+        </p:txBody>
+      </p:sp>
+      <p:sp>
+        <p:nvSpPr>
+          <p:cNvPr id="22" name="Text 20"/>
+          <p:cNvSpPr/>
+          <p:nvPr/>
+        </p:nvSpPr>
+        <p:spPr>
+          <a:xfrm>
+            <a:off x="1188720" y="4078224"/>
+            <a:ext cx="4480560" cy="585216"/>
           </a:xfrm>
           <a:prstGeom prst="rect">
             <a:avLst/>
@@ -12562,12 +14115,12 @@
           <a:p>
             <a:pPr indent="0" marL="0">
               <a:lnSpc>
-                <a:spcPct val="108000"/>
+                <a:spcPct val="103000"/>
               </a:lnSpc>
               <a:buNone/>
             </a:pPr>
             <a:r>
-              <a:rPr lang="en-US" sz="1250" dirty="0">
+              <a:rPr lang="en-US" sz="1100" dirty="0">
                 <a:solidFill>
                   <a:srgbClr val="93A1AF"/>
                 </a:solidFill>
@@ -12575,21 +14128,55 @@
                 <a:ea typeface="Calibri" pitchFamily="34" charset="-122"/>
                 <a:cs typeface="Calibri" pitchFamily="34" charset="-120"/>
               </a:rPr>
-              <a:t>Anomalies are events beyond 3σ of the live population — the threshold moves with the data, not a magic number.</a:t>
-            </a:r>
-            <a:endParaRPr lang="en-US" sz="1250" dirty="0"/>
-          </a:p>
-        </p:txBody>
-      </p:sp>
-      <p:sp>
-        <p:nvSpPr>
-          <p:cNvPr id="9" name="Shape 6"/>
-          <p:cNvSpPr/>
-          <p:nvPr/>
-        </p:nvSpPr>
-        <p:spPr>
-          <a:xfrm>
-            <a:off x="7772400" y="3099816"/>
+              <a:t>Records are never rewritten. A log you can edit in place is not evidence — and it can be tailed straight to a SIEM.</a:t>
+            </a:r>
+            <a:endParaRPr lang="en-US" sz="1100" dirty="0"/>
+          </a:p>
+        </p:txBody>
+      </p:sp>
+      <p:sp>
+        <p:nvSpPr>
+          <p:cNvPr id="23" name="Shape 21"/>
+          <p:cNvSpPr/>
+          <p:nvPr/>
+        </p:nvSpPr>
+        <p:spPr>
+          <a:xfrm>
+            <a:off x="6217920" y="3675888"/>
+            <a:ext cx="5257800" cy="1051560"/>
+          </a:xfrm>
+          <a:prstGeom prst="roundRect">
+            <a:avLst>
+              <a:gd name="adj" fmla="val 7826"/>
+            </a:avLst>
+          </a:prstGeom>
+          <a:solidFill>
+            <a:srgbClr val="18232F"/>
+          </a:solidFill>
+          <a:ln w="12700">
+            <a:solidFill>
+              <a:srgbClr val="2A3745"/>
+            </a:solidFill>
+            <a:prstDash val="solid"/>
+          </a:ln>
+          <a:effectLst>
+            <a:outerShdw sx="100000" sy="100000" kx="0" ky="0" algn="bl" rotWithShape="0" blurRad="114300" dist="38100" dir="5400000">
+              <a:srgbClr val="000000">
+                <a:alpha val="28000"/>
+              </a:srgbClr>
+            </a:outerShdw>
+          </a:effectLst>
+        </p:spPr>
+      </p:sp>
+      <p:sp>
+        <p:nvSpPr>
+          <p:cNvPr id="24" name="Shape 22"/>
+          <p:cNvSpPr/>
+          <p:nvPr/>
+        </p:nvSpPr>
+        <p:spPr>
+          <a:xfrm>
+            <a:off x="6492240" y="3895344"/>
             <a:ext cx="146304" cy="146304"/>
           </a:xfrm>
           <a:prstGeom prst="ellipse">
@@ -12603,30 +14190,30 @@
       </p:sp>
       <p:sp>
         <p:nvSpPr>
-          <p:cNvPr id="10" name="Text 7"/>
-          <p:cNvSpPr/>
-          <p:nvPr/>
-        </p:nvSpPr>
-        <p:spPr>
-          <a:xfrm>
-            <a:off x="8046720" y="2980944"/>
-            <a:ext cx="3474720" cy="365760"/>
-          </a:xfrm>
-          <a:prstGeom prst="rect">
-            <a:avLst/>
-          </a:prstGeom>
-          <a:noFill/>
-          <a:ln/>
-        </p:spPr>
-        <p:txBody>
-          <a:bodyPr wrap="square" lIns="0" tIns="0" rIns="0" bIns="0" rtlCol="0" anchor="ctr"/>
-          <a:lstStyle/>
-          <a:p>
-            <a:pPr indent="0" marL="0">
-              <a:buNone/>
-            </a:pPr>
-            <a:r>
-              <a:rPr lang="en-US" sz="1550" b="1" dirty="0">
+          <p:cNvPr id="25" name="Text 23"/>
+          <p:cNvSpPr/>
+          <p:nvPr/>
+        </p:nvSpPr>
+        <p:spPr>
+          <a:xfrm>
+            <a:off x="6766560" y="3785616"/>
+            <a:ext cx="4480560" cy="292608"/>
+          </a:xfrm>
+          <a:prstGeom prst="rect">
+            <a:avLst/>
+          </a:prstGeom>
+          <a:noFill/>
+          <a:ln/>
+        </p:spPr>
+        <p:txBody>
+          <a:bodyPr wrap="square" lIns="0" tIns="0" rIns="0" bIns="0" rtlCol="0" anchor="ctr"/>
+          <a:lstStyle/>
+          <a:p>
+            <a:pPr indent="0" marL="0">
+              <a:buNone/>
+            </a:pPr>
+            <a:r>
+              <a:rPr lang="en-US" sz="1400" b="1" dirty="0">
                 <a:solidFill>
                   <a:srgbClr val="E9EEF3"/>
                 </a:solidFill>
@@ -12634,22 +14221,22 @@
                 <a:ea typeface="Calibri" pitchFamily="34" charset="-122"/>
                 <a:cs typeface="Calibri" pitchFamily="34" charset="-120"/>
               </a:rPr>
-              <a:t>Parameter-bound execution</a:t>
-            </a:r>
-            <a:endParaRPr lang="en-US" sz="1550" dirty="0"/>
-          </a:p>
-        </p:txBody>
-      </p:sp>
-      <p:sp>
-        <p:nvSpPr>
-          <p:cNvPr id="11" name="Text 8"/>
-          <p:cNvSpPr/>
-          <p:nvPr/>
-        </p:nvSpPr>
-        <p:spPr>
-          <a:xfrm>
-            <a:off x="8046720" y="3364992"/>
-            <a:ext cx="3474720" cy="822960"/>
+              <a:t>Refusals are the point</a:t>
+            </a:r>
+            <a:endParaRPr lang="en-US" sz="1400" dirty="0"/>
+          </a:p>
+        </p:txBody>
+      </p:sp>
+      <p:sp>
+        <p:nvSpPr>
+          <p:cNvPr id="26" name="Text 24"/>
+          <p:cNvSpPr/>
+          <p:nvPr/>
+        </p:nvSpPr>
+        <p:spPr>
+          <a:xfrm>
+            <a:off x="6766560" y="4078224"/>
+            <a:ext cx="4480560" cy="585216"/>
           </a:xfrm>
           <a:prstGeom prst="rect">
             <a:avLst/>
@@ -12663,12 +14250,12 @@
           <a:p>
             <a:pPr indent="0" marL="0">
               <a:lnSpc>
-                <a:spcPct val="108000"/>
+                <a:spcPct val="103000"/>
               </a:lnSpc>
               <a:buNone/>
             </a:pPr>
             <a:r>
-              <a:rPr lang="en-US" sz="1250" dirty="0">
+              <a:rPr lang="en-US" sz="1100" dirty="0">
                 <a:solidFill>
                   <a:srgbClr val="93A1AF"/>
                 </a:solidFill>
@@ -12676,21 +14263,55 @@
                 <a:ea typeface="Calibri" pitchFamily="34" charset="-122"/>
                 <a:cs typeface="Calibri" pitchFamily="34" charset="-120"/>
               </a:rPr>
-              <a:t>Values are bound, never interpolated — a hostile input matches no rows and cannot reshape a query.</a:t>
-            </a:r>
-            <a:endParaRPr lang="en-US" sz="1250" dirty="0"/>
-          </a:p>
-        </p:txBody>
-      </p:sp>
-      <p:sp>
-        <p:nvSpPr>
-          <p:cNvPr id="12" name="Shape 9"/>
-          <p:cNvSpPr/>
-          <p:nvPr/>
-        </p:nvSpPr>
-        <p:spPr>
-          <a:xfrm>
-            <a:off x="7772400" y="4434840"/>
+              <a:t>A denial is the control working. It is recorded with the control that made it and the request that triggered it.</a:t>
+            </a:r>
+            <a:endParaRPr lang="en-US" sz="1100" dirty="0"/>
+          </a:p>
+        </p:txBody>
+      </p:sp>
+      <p:sp>
+        <p:nvSpPr>
+          <p:cNvPr id="27" name="Shape 25"/>
+          <p:cNvSpPr/>
+          <p:nvPr/>
+        </p:nvSpPr>
+        <p:spPr>
+          <a:xfrm>
+            <a:off x="640080" y="4892040"/>
+            <a:ext cx="5257800" cy="1051560"/>
+          </a:xfrm>
+          <a:prstGeom prst="roundRect">
+            <a:avLst>
+              <a:gd name="adj" fmla="val 7826"/>
+            </a:avLst>
+          </a:prstGeom>
+          <a:solidFill>
+            <a:srgbClr val="18232F"/>
+          </a:solidFill>
+          <a:ln w="12700">
+            <a:solidFill>
+              <a:srgbClr val="2A3745"/>
+            </a:solidFill>
+            <a:prstDash val="solid"/>
+          </a:ln>
+          <a:effectLst>
+            <a:outerShdw sx="100000" sy="100000" kx="0" ky="0" algn="bl" rotWithShape="0" blurRad="114300" dist="38100" dir="5400000">
+              <a:srgbClr val="000000">
+                <a:alpha val="28000"/>
+              </a:srgbClr>
+            </a:outerShdw>
+          </a:effectLst>
+        </p:spPr>
+      </p:sp>
+      <p:sp>
+        <p:nvSpPr>
+          <p:cNvPr id="28" name="Shape 26"/>
+          <p:cNvSpPr/>
+          <p:nvPr/>
+        </p:nvSpPr>
+        <p:spPr>
+          <a:xfrm>
+            <a:off x="914400" y="5111496"/>
             <a:ext cx="146304" cy="146304"/>
           </a:xfrm>
           <a:prstGeom prst="ellipse">
@@ -12704,30 +14325,30 @@
       </p:sp>
       <p:sp>
         <p:nvSpPr>
-          <p:cNvPr id="13" name="Text 10"/>
-          <p:cNvSpPr/>
-          <p:nvPr/>
-        </p:nvSpPr>
-        <p:spPr>
-          <a:xfrm>
-            <a:off x="8046720" y="4315968"/>
-            <a:ext cx="3474720" cy="365760"/>
-          </a:xfrm>
-          <a:prstGeom prst="rect">
-            <a:avLst/>
-          </a:prstGeom>
-          <a:noFill/>
-          <a:ln/>
-        </p:spPr>
-        <p:txBody>
-          <a:bodyPr wrap="square" lIns="0" tIns="0" rIns="0" bIns="0" rtlCol="0" anchor="ctr"/>
-          <a:lstStyle/>
-          <a:p>
-            <a:pPr indent="0" marL="0">
-              <a:buNone/>
-            </a:pPr>
-            <a:r>
-              <a:rPr lang="en-US" sz="1550" b="1" dirty="0">
+          <p:cNvPr id="29" name="Text 27"/>
+          <p:cNvSpPr/>
+          <p:nvPr/>
+        </p:nvSpPr>
+        <p:spPr>
+          <a:xfrm>
+            <a:off x="1188720" y="5001768"/>
+            <a:ext cx="4480560" cy="292608"/>
+          </a:xfrm>
+          <a:prstGeom prst="rect">
+            <a:avLst/>
+          </a:prstGeom>
+          <a:noFill/>
+          <a:ln/>
+        </p:spPr>
+        <p:txBody>
+          <a:bodyPr wrap="square" lIns="0" tIns="0" rIns="0" bIns="0" rtlCol="0" anchor="ctr"/>
+          <a:lstStyle/>
+          <a:p>
+            <a:pPr indent="0" marL="0">
+              <a:buNone/>
+            </a:pPr>
+            <a:r>
+              <a:rPr lang="en-US" sz="1400" b="1" dirty="0">
                 <a:solidFill>
                   <a:srgbClr val="E9EEF3"/>
                 </a:solidFill>
@@ -12735,22 +14356,22 @@
                 <a:ea typeface="Calibri" pitchFamily="34" charset="-122"/>
                 <a:cs typeface="Calibri" pitchFamily="34" charset="-120"/>
               </a:rPr>
-              <a:t>Every step is traced</a:t>
-            </a:r>
-            <a:endParaRPr lang="en-US" sz="1550" dirty="0"/>
-          </a:p>
-        </p:txBody>
-      </p:sp>
-      <p:sp>
-        <p:nvSpPr>
-          <p:cNvPr id="14" name="Text 11"/>
-          <p:cNvSpPr/>
-          <p:nvPr/>
-        </p:nvSpPr>
-        <p:spPr>
-          <a:xfrm>
-            <a:off x="8046720" y="4700016"/>
-            <a:ext cx="3474720" cy="822960"/>
+              <a:t>Queryable, exportable</a:t>
+            </a:r>
+            <a:endParaRPr lang="en-US" sz="1400" dirty="0"/>
+          </a:p>
+        </p:txBody>
+      </p:sp>
+      <p:sp>
+        <p:nvSpPr>
+          <p:cNvPr id="30" name="Text 28"/>
+          <p:cNvSpPr/>
+          <p:nvPr/>
+        </p:nvSpPr>
+        <p:spPr>
+          <a:xfrm>
+            <a:off x="1188720" y="5294376"/>
+            <a:ext cx="4480560" cy="585216"/>
           </a:xfrm>
           <a:prstGeom prst="rect">
             <a:avLst/>
@@ -12764,12 +14385,12 @@
           <a:p>
             <a:pPr indent="0" marL="0">
               <a:lnSpc>
-                <a:spcPct val="108000"/>
+                <a:spcPct val="103000"/>
               </a:lnSpc>
               <a:buNone/>
             </a:pPr>
             <a:r>
-              <a:rPr lang="en-US" sz="1250" dirty="0">
+              <a:rPr lang="en-US" sz="1100" dirty="0">
                 <a:solidFill>
                   <a:srgbClr val="93A1AF"/>
                 </a:solidFill>
@@ -12777,38 +14398,173 @@
                 <a:ea typeface="Calibri" pitchFamily="34" charset="-122"/>
                 <a:cs typeface="Calibri" pitchFamily="34" charset="-120"/>
               </a:rPr>
-              <a:t>Intent, each governance decision, execution, synthesis — all recorded, so an answer is auditable end to end.</a:t>
-            </a:r>
-            <a:endParaRPr lang="en-US" sz="1250" dirty="0"/>
-          </a:p>
-        </p:txBody>
-      </p:sp>
-      <p:sp>
-        <p:nvSpPr>
-          <p:cNvPr id="15" name="Text 12"/>
-          <p:cNvSpPr/>
-          <p:nvPr/>
-        </p:nvSpPr>
-        <p:spPr>
-          <a:xfrm>
-            <a:off x="640080" y="5943600"/>
-            <a:ext cx="10881360" cy="457200"/>
-          </a:xfrm>
-          <a:prstGeom prst="rect">
-            <a:avLst/>
-          </a:prstGeom>
-          <a:noFill/>
-          <a:ln/>
-        </p:spPr>
-        <p:txBody>
-          <a:bodyPr wrap="square" lIns="0" tIns="0" rIns="0" bIns="0" rtlCol="0" anchor="ctr"/>
-          <a:lstStyle/>
-          <a:p>
-            <a:pPr indent="0" marL="0">
-              <a:buNone/>
-            </a:pPr>
-            <a:r>
-              <a:rPr lang="en-US" sz="1450" i="1" dirty="0">
+              <a:t>“Show me everything the AI did” is a SQL question, with a CSV extract for the auditor.</a:t>
+            </a:r>
+            <a:endParaRPr lang="en-US" sz="1100" dirty="0"/>
+          </a:p>
+        </p:txBody>
+      </p:sp>
+      <p:sp>
+        <p:nvSpPr>
+          <p:cNvPr id="31" name="Shape 29"/>
+          <p:cNvSpPr/>
+          <p:nvPr/>
+        </p:nvSpPr>
+        <p:spPr>
+          <a:xfrm>
+            <a:off x="6217920" y="4892040"/>
+            <a:ext cx="5257800" cy="1051560"/>
+          </a:xfrm>
+          <a:prstGeom prst="roundRect">
+            <a:avLst>
+              <a:gd name="adj" fmla="val 7826"/>
+            </a:avLst>
+          </a:prstGeom>
+          <a:solidFill>
+            <a:srgbClr val="18232F"/>
+          </a:solidFill>
+          <a:ln w="12700">
+            <a:solidFill>
+              <a:srgbClr val="2A3745"/>
+            </a:solidFill>
+            <a:prstDash val="solid"/>
+          </a:ln>
+          <a:effectLst>
+            <a:outerShdw sx="100000" sy="100000" kx="0" ky="0" algn="bl" rotWithShape="0" blurRad="114300" dist="38100" dir="5400000">
+              <a:srgbClr val="000000">
+                <a:alpha val="28000"/>
+              </a:srgbClr>
+            </a:outerShdw>
+          </a:effectLst>
+        </p:spPr>
+      </p:sp>
+      <p:sp>
+        <p:nvSpPr>
+          <p:cNvPr id="32" name="Shape 30"/>
+          <p:cNvSpPr/>
+          <p:nvPr/>
+        </p:nvSpPr>
+        <p:spPr>
+          <a:xfrm>
+            <a:off x="6492240" y="5111496"/>
+            <a:ext cx="146304" cy="146304"/>
+          </a:xfrm>
+          <a:prstGeom prst="ellipse">
+            <a:avLst/>
+          </a:prstGeom>
+          <a:solidFill>
+            <a:srgbClr val="FF6C00"/>
+          </a:solidFill>
+          <a:ln/>
+        </p:spPr>
+      </p:sp>
+      <p:sp>
+        <p:nvSpPr>
+          <p:cNvPr id="33" name="Text 31"/>
+          <p:cNvSpPr/>
+          <p:nvPr/>
+        </p:nvSpPr>
+        <p:spPr>
+          <a:xfrm>
+            <a:off x="6766560" y="5001768"/>
+            <a:ext cx="4480560" cy="292608"/>
+          </a:xfrm>
+          <a:prstGeom prst="rect">
+            <a:avLst/>
+          </a:prstGeom>
+          <a:noFill/>
+          <a:ln/>
+        </p:spPr>
+        <p:txBody>
+          <a:bodyPr wrap="square" lIns="0" tIns="0" rIns="0" bIns="0" rtlCol="0" anchor="ctr"/>
+          <a:lstStyle/>
+          <a:p>
+            <a:pPr indent="0" marL="0">
+              <a:buNone/>
+            </a:pPr>
+            <a:r>
+              <a:rPr lang="en-US" sz="1400" b="1" dirty="0">
+                <a:solidFill>
+                  <a:srgbClr val="E9EEF3"/>
+                </a:solidFill>
+                <a:latin typeface="Calibri" pitchFamily="34" charset="0"/>
+                <a:ea typeface="Calibri" pitchFamily="34" charset="-122"/>
+                <a:cs typeface="Calibri" pitchFamily="34" charset="-120"/>
+              </a:rPr>
+              <a:t>Never fails the request</a:t>
+            </a:r>
+            <a:endParaRPr lang="en-US" sz="1400" dirty="0"/>
+          </a:p>
+        </p:txBody>
+      </p:sp>
+      <p:sp>
+        <p:nvSpPr>
+          <p:cNvPr id="34" name="Text 32"/>
+          <p:cNvSpPr/>
+          <p:nvPr/>
+        </p:nvSpPr>
+        <p:spPr>
+          <a:xfrm>
+            <a:off x="6766560" y="5294376"/>
+            <a:ext cx="4480560" cy="585216"/>
+          </a:xfrm>
+          <a:prstGeom prst="rect">
+            <a:avLst/>
+          </a:prstGeom>
+          <a:noFill/>
+          <a:ln/>
+        </p:spPr>
+        <p:txBody>
+          <a:bodyPr wrap="square" lIns="0" tIns="0" rIns="0" bIns="0" rtlCol="0" anchor="ctr"/>
+          <a:lstStyle/>
+          <a:p>
+            <a:pPr indent="0" marL="0">
+              <a:lnSpc>
+                <a:spcPct val="103000"/>
+              </a:lnSpc>
+              <a:buNone/>
+            </a:pPr>
+            <a:r>
+              <a:rPr lang="en-US" sz="1100" dirty="0">
+                <a:solidFill>
+                  <a:srgbClr val="93A1AF"/>
+                </a:solidFill>
+                <a:latin typeface="Calibri" pitchFamily="34" charset="0"/>
+                <a:ea typeface="Calibri" pitchFamily="34" charset="-122"/>
+                <a:cs typeface="Calibri" pitchFamily="34" charset="-120"/>
+              </a:rPr>
+              <a:t>An audit sink that can take the service down is a liability. Write failures are logged and swallowed.</a:t>
+            </a:r>
+            <a:endParaRPr lang="en-US" sz="1100" dirty="0"/>
+          </a:p>
+        </p:txBody>
+      </p:sp>
+      <p:sp>
+        <p:nvSpPr>
+          <p:cNvPr id="35" name="Text 33"/>
+          <p:cNvSpPr/>
+          <p:nvPr/>
+        </p:nvSpPr>
+        <p:spPr>
+          <a:xfrm>
+            <a:off x="640080" y="6035040"/>
+            <a:ext cx="10881360" cy="274320"/>
+          </a:xfrm>
+          <a:prstGeom prst="rect">
+            <a:avLst/>
+          </a:prstGeom>
+          <a:noFill/>
+          <a:ln/>
+        </p:spPr>
+        <p:txBody>
+          <a:bodyPr wrap="square" lIns="0" tIns="0" rIns="0" bIns="0" rtlCol="0" anchor="ctr"/>
+          <a:lstStyle/>
+          <a:p>
+            <a:pPr indent="0" marL="0">
+              <a:buNone/>
+            </a:pPr>
+            <a:r>
+              <a:rPr lang="en-US" sz="1400" i="1" dirty="0">
                 <a:solidFill>
                   <a:srgbClr val="FF8A3D"/>
                 </a:solidFill>
@@ -12816,15 +14572,15 @@
                 <a:ea typeface="Calibri" pitchFamily="34" charset="-122"/>
                 <a:cs typeface="Calibri" pitchFamily="34" charset="-120"/>
               </a:rPr>
-              <a:t>Verified by a 29-test suite covering real computation, governance enforcement, injection resistance, retrieval quality, and abstention — all passing.</a:t>
-            </a:r>
-            <a:endParaRPr lang="en-US" sz="1450" dirty="0"/>
-          </a:p>
-        </p:txBody>
-      </p:sp>
-      <p:sp>
-        <p:nvSpPr>
-          <p:cNvPr id="16" name="Text 13"/>
+              <a:t>Kill the process, restart it, and the trail is still there — that is the difference between logging and evidence.</a:t>
+            </a:r>
+            <a:endParaRPr lang="en-US" sz="1400" dirty="0"/>
+          </a:p>
+        </p:txBody>
+      </p:sp>
+      <p:sp>
+        <p:nvSpPr>
+          <p:cNvPr id="36" name="Text 34"/>
           <p:cNvSpPr/>
           <p:nvPr/>
         </p:nvSpPr>
@@ -12863,7 +14619,7 @@
       </p:sp>
       <p:sp>
         <p:nvSpPr>
-          <p:cNvPr id="17" name="Text 14"/>
+          <p:cNvPr id="37" name="Text 35"/>
           <p:cNvSpPr/>
           <p:nvPr/>
         </p:nvSpPr>

</xml_diff>